<commit_message>
Remove columns in charts for simplicity
</commit_message>
<xml_diff>
--- a/docs/p1.pptx
+++ b/docs/p1.pptx
@@ -3892,7 +3892,7 @@
             <a:pPr lvl="1"/>
             <a:r>
               <a:rPr/>
-              <a:t>To prove quality so that…</a:t>
+              <a:t>To prove quality</a:t>
             </a:r>
           </a:p>
           <a:p>
@@ -3901,7 +3901,7 @@
             </a:pPr>
             <a:r>
               <a:rPr/>
-              <a:t>Team Leaders/Release Controllers will:</a:t>
+              <a:t>Create a Pull Request (PR) to signal to Team Leaders/Release Controllers to:</a:t>
             </a:r>
           </a:p>
           <a:p>

</xml_diff>

<commit_message>
Switched back to the light theme
</commit_message>
<xml_diff>
--- a/docs/p1.pptx
+++ b/docs/p1.pptx
@@ -13,8 +13,6 @@
     <p:sldId id="261" r:id="rId7"/>
     <p:sldId id="262" r:id="rId8"/>
     <p:sldId id="263" r:id="rId9"/>
-    <p:sldId id="264" r:id="rId10"/>
-    <p:sldId id="265" r:id="rId11"/>
   </p:sldIdLst>
   <p:sldSz cx="9144000" cy="5143500" type="screen16x9"/>
   <p:notesSz cx="6858000" cy="9144000"/>
@@ -3150,105 +3148,6 @@
 </p:sld>
 </file>
 
-<file path=ppt/slides/slide10.xml><?xml version="1.0" encoding="utf-8"?>
-<p:sld xmlns:a="http://schemas.openxmlformats.org/drawingml/2006/main" xmlns:r="http://schemas.openxmlformats.org/officeDocument/2006/relationships" xmlns:p="http://schemas.openxmlformats.org/presentationml/2006/main">
-  <p:cSld>
-    <p:spTree>
-      <p:nvGrpSpPr>
-        <p:cNvPr id="1" name=""/>
-        <p:cNvGrpSpPr/>
-        <p:nvPr/>
-      </p:nvGrpSpPr>
-      <p:grpSpPr>
-        <a:xfrm>
-          <a:off x="0" y="0"/>
-          <a:ext cx="0" cy="0"/>
-          <a:chOff x="0" y="0"/>
-          <a:chExt cx="0" cy="0"/>
-        </a:xfrm>
-      </p:grpSpPr>
-      <p:sp>
-        <p:nvSpPr>
-          <p:cNvPr id="2" name="Title 1"/>
-          <p:cNvSpPr>
-            <a:spLocks noGrp="1"/>
-          </p:cNvSpPr>
-          <p:nvPr>
-            <p:ph type="title"/>
-          </p:nvPr>
-        </p:nvSpPr>
-        <p:spPr/>
-        <p:txBody>
-          <a:bodyPr/>
-          <a:lstStyle/>
-          <a:p>
-            <a:pPr lvl="0" indent="0" marL="0">
-              <a:buNone/>
-            </a:pPr>
-            <a:r>
-              <a:rPr/>
-              <a:t>Worflows supported by the strategy</a:t>
-            </a:r>
-          </a:p>
-        </p:txBody>
-      </p:sp>
-      <p:sp>
-        <p:nvSpPr>
-          <p:cNvPr id="3" name="Content Placeholder 2"/>
-          <p:cNvSpPr>
-            <a:spLocks noGrp="1"/>
-          </p:cNvSpPr>
-          <p:nvPr>
-            <p:ph idx="1"/>
-          </p:nvPr>
-        </p:nvSpPr>
-        <p:spPr/>
-        <p:txBody>
-          <a:bodyPr/>
-          <a:lstStyle/>
-          <a:p>
-            <a:pPr lvl="0" indent="0" marL="0">
-              <a:spcBef>
-                <a:spcPts val="3000"/>
-              </a:spcBef>
-              <a:buNone/>
-            </a:pPr>
-            <a:r>
-              <a:rPr b="1"/>
-              <a:t>Delivering changes via a release</a:t>
-            </a:r>
-          </a:p>
-          <a:p>
-            <a:pPr lvl="0" indent="0" marL="0">
-              <a:spcBef>
-                <a:spcPts val="3000"/>
-              </a:spcBef>
-              <a:buNone/>
-            </a:pPr>
-            <a:r>
-              <a:rPr b="1"/>
-              <a:t>Hot-fix for production</a:t>
-            </a:r>
-          </a:p>
-          <a:p>
-            <a:pPr lvl="0" indent="0" marL="0">
-              <a:spcBef>
-                <a:spcPts val="3000"/>
-              </a:spcBef>
-              <a:buNone/>
-            </a:pPr>
-            <a:r>
-              <a:rPr b="1"/>
-              <a:t>Using an Epic branch</a:t>
-            </a:r>
-          </a:p>
-        </p:txBody>
-      </p:sp>
-    </p:spTree>
-  </p:cSld>
-</p:sld>
-</file>
-
 <file path=ppt/slides/slide2.xml><?xml version="1.0" encoding="utf-8"?>
 <p:sld xmlns:a="http://schemas.openxmlformats.org/drawingml/2006/main" xmlns:r="http://schemas.openxmlformats.org/officeDocument/2006/relationships" xmlns:p="http://schemas.openxmlformats.org/presentationml/2006/main">
   <p:cSld>
@@ -3429,6 +3328,104 @@
             </a:pPr>
             <a:r>
               <a:rPr b="1"/>
+              <a:t>No baggage</a:t>
+            </a:r>
+          </a:p>
+          <a:p>
+            <a:pPr lvl="0" indent="0" marL="0">
+              <a:buNone/>
+            </a:pPr>
+            <a:r>
+              <a:rPr/>
+              <a:t>Well… </a:t>
+            </a:r>
+            <a:r>
+              <a:rPr i="1"/>
+              <a:t>“travel light”</a:t>
+            </a:r>
+            <a:r>
+              <a:rPr/>
+              <a:t> perhaps!</a:t>
+            </a:r>
+          </a:p>
+          <a:p>
+            <a:pPr lvl="0"/>
+            <a:r>
+              <a:rPr/>
+              <a:t>Are we </a:t>
+            </a:r>
+            <a:r>
+              <a:rPr i="1"/>
+              <a:t>prescriptive</a:t>
+            </a:r>
+            <a:r>
+              <a:rPr/>
+              <a:t> or just </a:t>
+            </a:r>
+            <a:r>
+              <a:rPr i="1"/>
+              <a:t>opinionated</a:t>
+            </a:r>
+            <a:r>
+              <a:rPr/>
+              <a:t>?</a:t>
+            </a:r>
+          </a:p>
+          <a:p>
+            <a:pPr lvl="0"/>
+            <a:r>
+              <a:rPr/>
+              <a:t>We start with a recommendation</a:t>
+            </a:r>
+          </a:p>
+          <a:p>
+            <a:pPr lvl="1"/>
+            <a:r>
+              <a:rPr/>
+              <a:t>Confidently</a:t>
+            </a:r>
+          </a:p>
+          <a:p>
+            <a:pPr lvl="0"/>
+            <a:r>
+              <a:rPr/>
+              <a:t>We question everything</a:t>
+            </a:r>
+          </a:p>
+          <a:p>
+            <a:pPr lvl="1"/>
+            <a:r>
+              <a:rPr b="1"/>
+              <a:t>YAGNI</a:t>
+            </a:r>
+            <a:r>
+              <a:rPr/>
+              <a:t> - “you aren’t gonna need it”</a:t>
+            </a:r>
+          </a:p>
+          <a:p>
+            <a:pPr lvl="0"/>
+            <a:r>
+              <a:rPr/>
+              <a:t>We strive for simplicity</a:t>
+            </a:r>
+          </a:p>
+          <a:p>
+            <a:pPr lvl="1"/>
+            <a:r>
+              <a:rPr/>
+              <a:t>For each user’s experience</a:t>
+            </a:r>
+          </a:p>
+          <a:p>
+            <a:pPr lvl="0" indent="0" marL="0">
+              <a:spcBef>
+                <a:spcPts val="3000"/>
+              </a:spcBef>
+              <a:buNone/>
+            </a:pPr>
+            <a:r>
+              <a:rPr b="1"/>
               <a:t>Scaling</a:t>
             </a:r>
           </a:p>
@@ -3527,7 +3524,12 @@
             <p:ph type="title"/>
           </p:nvPr>
         </p:nvSpPr>
-        <p:spPr/>
+        <p:spPr>
+          <a:xfrm>
+            <a:off x="457201" y="204787"/>
+            <a:ext cx="3008313" cy="871538"/>
+          </a:xfrm>
+        </p:spPr>
         <p:txBody>
           <a:bodyPr/>
           <a:lstStyle/>
@@ -3544,12 +3546,12 @@
       </p:sp>
       <p:sp>
         <p:nvSpPr>
-          <p:cNvPr id="3" name="Content Placeholder 2"/>
-          <p:cNvSpPr>
-            <a:spLocks noGrp="1"/>
-          </p:cNvSpPr>
-          <p:nvPr>
-            <p:ph idx="1"/>
+          <p:cNvPr id="4" name="Text Placeholder 3"/>
+          <p:cNvSpPr>
+            <a:spLocks noGrp="1"/>
+          </p:cNvSpPr>
+          <p:nvPr>
+            <p:ph idx="2" sz="half" type="body"/>
           </p:nvPr>
         </p:nvSpPr>
         <p:spPr/>
@@ -3565,11 +3567,50 @@
             </a:pPr>
             <a:r>
               <a:rPr b="1"/>
-              <a:t>Starting Simple 1</a:t>
-            </a:r>
-          </a:p>
-        </p:txBody>
-      </p:sp>
+              <a:t>Starting Simple</a:t>
+            </a:r>
+          </a:p>
+          <a:p>
+            <a:pPr lvl="0" indent="0" marL="0">
+              <a:buNone/>
+            </a:pPr>
+            <a:r>
+              <a:rPr/>
+              <a:t>Every change starts in a branch.</a:t>
+            </a:r>
+          </a:p>
+        </p:txBody>
+      </p:sp>
+      <p:pic>
+        <p:nvPicPr>
+          <p:cNvPr descr="static/img/branching-model/image5.png" id="0" name="Picture 1"/>
+          <p:cNvPicPr>
+            <a:picLocks noGrp="1" noChangeAspect="1"/>
+          </p:cNvPicPr>
+          <p:nvPr/>
+        </p:nvPicPr>
+        <p:blipFill>
+          <a:blip r:embed="rId2"/>
+          <a:stretch>
+            <a:fillRect/>
+          </a:stretch>
+        </p:blipFill>
+        <p:spPr bwMode="auto">
+          <a:xfrm>
+            <a:off x="3568700" y="1765300"/>
+            <a:ext cx="5105400" cy="1257300"/>
+          </a:xfrm>
+          <a:prstGeom prst="rect">
+            <a:avLst/>
+          </a:prstGeom>
+          <a:noFill/>
+          <a:ln w="9525">
+            <a:noFill/>
+            <a:headEnd/>
+            <a:tailEnd/>
+          </a:ln>
+        </p:spPr>
+      </p:pic>
     </p:spTree>
   </p:cSld>
 </p:sld>
@@ -3594,12 +3635,12 @@
       </p:grpSpPr>
       <p:sp>
         <p:nvSpPr>
-          <p:cNvPr id="3" name="Content Placeholder 2"/>
-          <p:cNvSpPr>
-            <a:spLocks noGrp="1"/>
-          </p:cNvSpPr>
-          <p:nvPr>
-            <p:ph idx="1" sz="half"/>
+          <p:cNvPr id="4" name="Text Placeholder 3"/>
+          <p:cNvSpPr>
+            <a:spLocks noGrp="1"/>
+          </p:cNvSpPr>
+          <p:nvPr>
+            <p:ph idx="2" sz="half" type="body"/>
           </p:nvPr>
         </p:nvSpPr>
         <p:spPr/>
@@ -3607,19 +3648,45 @@
           <a:bodyPr/>
           <a:lstStyle/>
           <a:p>
+            <a:pPr lvl="0"/>
+            <a:r>
+              <a:rPr/>
+              <a:t>Developers work in the branch to make changes, perform user builds and unit tests.</a:t>
+            </a:r>
+          </a:p>
+          <a:p>
+            <a:pPr lvl="0"/>
+            <a:r>
+              <a:rPr/>
+              <a:t>A branch holds multiple commits (changes to multiple files).</a:t>
+            </a:r>
+          </a:p>
+          <a:p>
             <a:pPr lvl="0" indent="0" marL="0">
+              <a:spcBef>
+                <a:spcPts val="3000"/>
+              </a:spcBef>
               <a:buNone/>
             </a:pPr>
             <a:r>
-              <a:rPr/>
-              <a:t>Every change starts in a branch</a:t>
+              <a:rPr b="1"/>
+              <a:t>Starting Simple</a:t>
+            </a:r>
+          </a:p>
+          <a:p>
+            <a:pPr lvl="0" indent="0" marL="0">
+              <a:buNone/>
+            </a:pPr>
+            <a:r>
+              <a:rPr/>
+              <a:t>Every change starts in a branch.</a:t>
             </a:r>
           </a:p>
         </p:txBody>
       </p:sp>
       <p:pic>
         <p:nvPicPr>
-          <p:cNvPr descr="static/img/branching-model/image5.png" id="0" name="Picture 1"/>
+          <p:cNvPr descr="static/img/branching-model/image6.png" id="0" name="Picture 1"/>
           <p:cNvPicPr>
             <a:picLocks noGrp="1" noChangeAspect="1"/>
           </p:cNvPicPr>
@@ -3633,8 +3700,8 @@
         </p:blipFill>
         <p:spPr bwMode="auto">
           <a:xfrm>
-            <a:off x="4648200" y="2387600"/>
-            <a:ext cx="4038600" cy="990600"/>
+            <a:off x="3568700" y="1854200"/>
+            <a:ext cx="5105400" cy="1066800"/>
           </a:xfrm>
           <a:prstGeom prst="rect">
             <a:avLst/>
@@ -3671,12 +3738,12 @@
       </p:grpSpPr>
       <p:sp>
         <p:nvSpPr>
-          <p:cNvPr id="3" name="Content Placeholder 2"/>
-          <p:cNvSpPr>
-            <a:spLocks noGrp="1"/>
-          </p:cNvSpPr>
-          <p:nvPr>
-            <p:ph idx="1"/>
+          <p:cNvPr id="4" name="Text Placeholder 3"/>
+          <p:cNvSpPr>
+            <a:spLocks noGrp="1"/>
+          </p:cNvSpPr>
+          <p:nvPr>
+            <p:ph idx="2" sz="half" type="body"/>
           </p:nvPr>
         </p:nvSpPr>
         <p:spPr/>
@@ -3689,7 +3756,45 @@
             </a:pPr>
             <a:r>
               <a:rPr/>
-              <a:t>Multiple commits (changes to multiple files) made to a branch by developers.</a:t>
+              <a:t>These branches are</a:t>
+            </a:r>
+          </a:p>
+          <a:p>
+            <a:pPr lvl="0"/>
+            <a:r>
+              <a:rPr/>
+              <a:t>built,</a:t>
+            </a:r>
+          </a:p>
+          <a:p>
+            <a:pPr lvl="0"/>
+            <a:r>
+              <a:rPr/>
+              <a:t>tested,</a:t>
+            </a:r>
+          </a:p>
+          <a:p>
+            <a:pPr lvl="0"/>
+            <a:r>
+              <a:rPr/>
+              <a:t>reviewed and</a:t>
+            </a:r>
+          </a:p>
+          <a:p>
+            <a:pPr lvl="0"/>
+            <a:r>
+              <a:rPr/>
+              <a:t>approved before merging to </a:t>
+            </a:r>
+            <a:r>
+              <a:rPr>
+                <a:latin typeface="Courier"/>
+              </a:rPr>
+              <a:t>main</a:t>
+            </a:r>
+            <a:r>
+              <a:rPr/>
+              <a:t>.</a:t>
             </a:r>
           </a:p>
           <a:p>
@@ -3701,139 +3806,6 @@
             </a:pPr>
             <a:r>
               <a:rPr b="1"/>
-              <a:t>Starting Simple 2</a:t>
-            </a:r>
-          </a:p>
-        </p:txBody>
-      </p:sp>
-    </p:spTree>
-  </p:cSld>
-</p:sld>
-</file>
-
-<file path=ppt/slides/slide7.xml><?xml version="1.0" encoding="utf-8"?>
-<p:sld xmlns:a="http://schemas.openxmlformats.org/drawingml/2006/main" xmlns:r="http://schemas.openxmlformats.org/officeDocument/2006/relationships" xmlns:p="http://schemas.openxmlformats.org/presentationml/2006/main">
-  <p:cSld>
-    <p:spTree>
-      <p:nvGrpSpPr>
-        <p:cNvPr id="1" name=""/>
-        <p:cNvGrpSpPr/>
-        <p:nvPr/>
-      </p:nvGrpSpPr>
-      <p:grpSpPr>
-        <a:xfrm>
-          <a:off x="0" y="0"/>
-          <a:ext cx="0" cy="0"/>
-          <a:chOff x="0" y="0"/>
-          <a:chExt cx="0" cy="0"/>
-        </a:xfrm>
-      </p:grpSpPr>
-      <p:sp>
-        <p:nvSpPr>
-          <p:cNvPr id="3" name="Content Placeholder 2"/>
-          <p:cNvSpPr>
-            <a:spLocks noGrp="1"/>
-          </p:cNvSpPr>
-          <p:nvPr>
-            <p:ph idx="1" sz="half"/>
-          </p:nvPr>
-        </p:nvSpPr>
-        <p:spPr/>
-        <p:txBody>
-          <a:bodyPr/>
-          <a:lstStyle/>
-          <a:p>
-            <a:pPr lvl="0" indent="0" marL="0">
-              <a:buNone/>
-            </a:pPr>
-            <a:r>
-              <a:rPr/>
-              <a:t>Every change starts in a branch   These branches merge to </a:t>
-            </a:r>
-            <a:r>
-              <a:rPr>
-                <a:latin typeface="Courier"/>
-              </a:rPr>
-              <a:t>main</a:t>
-            </a:r>
-          </a:p>
-        </p:txBody>
-      </p:sp>
-      <p:pic>
-        <p:nvPicPr>
-          <p:cNvPr descr="static/img/branching-model/image5.png" id="0" name="Picture 1"/>
-          <p:cNvPicPr>
-            <a:picLocks noGrp="1" noChangeAspect="1"/>
-          </p:cNvPicPr>
-          <p:nvPr/>
-        </p:nvPicPr>
-        <p:blipFill>
-          <a:blip r:embed="rId2"/>
-          <a:stretch>
-            <a:fillRect/>
-          </a:stretch>
-        </p:blipFill>
-        <p:spPr bwMode="auto">
-          <a:xfrm>
-            <a:off x="4648200" y="2387600"/>
-            <a:ext cx="4038600" cy="990600"/>
-          </a:xfrm>
-          <a:prstGeom prst="rect">
-            <a:avLst/>
-          </a:prstGeom>
-          <a:noFill/>
-          <a:ln w="9525">
-            <a:noFill/>
-            <a:headEnd/>
-            <a:tailEnd/>
-          </a:ln>
-        </p:spPr>
-      </p:pic>
-    </p:spTree>
-  </p:cSld>
-</p:sld>
-</file>
-
-<file path=ppt/slides/slide8.xml><?xml version="1.0" encoding="utf-8"?>
-<p:sld xmlns:a="http://schemas.openxmlformats.org/drawingml/2006/main" xmlns:r="http://schemas.openxmlformats.org/officeDocument/2006/relationships" xmlns:p="http://schemas.openxmlformats.org/presentationml/2006/main">
-  <p:cSld>
-    <p:spTree>
-      <p:nvGrpSpPr>
-        <p:cNvPr id="1" name=""/>
-        <p:cNvGrpSpPr/>
-        <p:nvPr/>
-      </p:nvGrpSpPr>
-      <p:grpSpPr>
-        <a:xfrm>
-          <a:off x="0" y="0"/>
-          <a:ext cx="0" cy="0"/>
-          <a:chOff x="0" y="0"/>
-          <a:chExt cx="0" cy="0"/>
-        </a:xfrm>
-      </p:grpSpPr>
-      <p:sp>
-        <p:nvSpPr>
-          <p:cNvPr id="4" name="Text Placeholder 3"/>
-          <p:cNvSpPr>
-            <a:spLocks noGrp="1"/>
-          </p:cNvSpPr>
-          <p:nvPr>
-            <p:ph idx="2" sz="half" type="body"/>
-          </p:nvPr>
-        </p:nvSpPr>
-        <p:spPr/>
-        <p:txBody>
-          <a:bodyPr/>
-          <a:lstStyle/>
-          <a:p>
-            <a:pPr lvl="0" indent="0" marL="0">
-              <a:spcBef>
-                <a:spcPts val="3000"/>
-              </a:spcBef>
-              <a:buNone/>
-            </a:pPr>
-            <a:r>
-              <a:rPr b="1"/>
               <a:t>Merging into </a:t>
             </a:r>
             <a:r>
@@ -3885,14 +3857,14 @@
             <a:pPr lvl="0"/>
             <a:r>
               <a:rPr/>
-              <a:t>Test their built feature</a:t>
+              <a:t>Test</a:t>
             </a:r>
           </a:p>
           <a:p>
             <a:pPr lvl="1"/>
             <a:r>
               <a:rPr/>
-              <a:t>To prove quality</a:t>
+              <a:t>To prove quality of the changes in their feature branch</a:t>
             </a:r>
           </a:p>
           <a:p>
@@ -4201,7 +4173,7 @@
 </p:sld>
 </file>
 
-<file path=ppt/slides/slide9.xml><?xml version="1.0" encoding="utf-8"?>
+<file path=ppt/slides/slide7.xml><?xml version="1.0" encoding="utf-8"?>
 <p:sld xmlns:a="http://schemas.openxmlformats.org/drawingml/2006/main" xmlns:r="http://schemas.openxmlformats.org/officeDocument/2006/relationships" xmlns:p="http://schemas.openxmlformats.org/presentationml/2006/main">
   <p:cSld>
     <p:spTree>
@@ -4377,6 +4349,105 @@
           </a:ln>
         </p:spPr>
       </p:pic>
+    </p:spTree>
+  </p:cSld>
+</p:sld>
+</file>
+
+<file path=ppt/slides/slide8.xml><?xml version="1.0" encoding="utf-8"?>
+<p:sld xmlns:a="http://schemas.openxmlformats.org/drawingml/2006/main" xmlns:r="http://schemas.openxmlformats.org/officeDocument/2006/relationships" xmlns:p="http://schemas.openxmlformats.org/presentationml/2006/main">
+  <p:cSld>
+    <p:spTree>
+      <p:nvGrpSpPr>
+        <p:cNvPr id="1" name=""/>
+        <p:cNvGrpSpPr/>
+        <p:nvPr/>
+      </p:nvGrpSpPr>
+      <p:grpSpPr>
+        <a:xfrm>
+          <a:off x="0" y="0"/>
+          <a:ext cx="0" cy="0"/>
+          <a:chOff x="0" y="0"/>
+          <a:chExt cx="0" cy="0"/>
+        </a:xfrm>
+      </p:grpSpPr>
+      <p:sp>
+        <p:nvSpPr>
+          <p:cNvPr id="2" name="Title 1"/>
+          <p:cNvSpPr>
+            <a:spLocks noGrp="1"/>
+          </p:cNvSpPr>
+          <p:nvPr>
+            <p:ph type="title"/>
+          </p:nvPr>
+        </p:nvSpPr>
+        <p:spPr/>
+        <p:txBody>
+          <a:bodyPr/>
+          <a:lstStyle/>
+          <a:p>
+            <a:pPr lvl="0" indent="0" marL="0">
+              <a:buNone/>
+            </a:pPr>
+            <a:r>
+              <a:rPr/>
+              <a:t>Worflows supported by the strategy</a:t>
+            </a:r>
+          </a:p>
+        </p:txBody>
+      </p:sp>
+      <p:sp>
+        <p:nvSpPr>
+          <p:cNvPr id="3" name="Content Placeholder 2"/>
+          <p:cNvSpPr>
+            <a:spLocks noGrp="1"/>
+          </p:cNvSpPr>
+          <p:nvPr>
+            <p:ph idx="1"/>
+          </p:nvPr>
+        </p:nvSpPr>
+        <p:spPr/>
+        <p:txBody>
+          <a:bodyPr/>
+          <a:lstStyle/>
+          <a:p>
+            <a:pPr lvl="0" indent="0" marL="0">
+              <a:spcBef>
+                <a:spcPts val="3000"/>
+              </a:spcBef>
+              <a:buNone/>
+            </a:pPr>
+            <a:r>
+              <a:rPr b="1"/>
+              <a:t>Delivering changes via a release</a:t>
+            </a:r>
+          </a:p>
+          <a:p>
+            <a:pPr lvl="0" indent="0" marL="0">
+              <a:spcBef>
+                <a:spcPts val="3000"/>
+              </a:spcBef>
+              <a:buNone/>
+            </a:pPr>
+            <a:r>
+              <a:rPr b="1"/>
+              <a:t>Hot-fix for production</a:t>
+            </a:r>
+          </a:p>
+          <a:p>
+            <a:pPr lvl="0" indent="0" marL="0">
+              <a:spcBef>
+                <a:spcPts val="3000"/>
+              </a:spcBef>
+              <a:buNone/>
+            </a:pPr>
+            <a:r>
+              <a:rPr b="1"/>
+              <a:t>Using an Epic branch</a:t>
+            </a:r>
+          </a:p>
+        </p:txBody>
+      </p:sp>
     </p:spTree>
   </p:cSld>
 </p:sld>

</xml_diff>

<commit_message>
logo and listing on index.md
</commit_message>
<xml_diff>
--- a/docs/p1.pptx
+++ b/docs/p1.pptx
@@ -13,6 +13,7 @@
     <p:sldId id="261" r:id="rId7"/>
     <p:sldId id="262" r:id="rId8"/>
     <p:sldId id="263" r:id="rId9"/>
+    <p:sldId id="264" r:id="rId10"/>
   </p:sldIdLst>
   <p:sldSz cx="9144000" cy="5143500" type="screen16x9"/>
   <p:notesSz cx="6858000" cy="9144000"/>
@@ -4381,6 +4382,36 @@
             <p:ph type="title"/>
           </p:nvPr>
         </p:nvSpPr>
+        <p:spPr>
+          <a:xfrm>
+            <a:off x="457201" y="204787"/>
+            <a:ext cx="3008313" cy="871538"/>
+          </a:xfrm>
+        </p:spPr>
+        <p:txBody>
+          <a:bodyPr/>
+          <a:lstStyle/>
+          <a:p>
+            <a:pPr lvl="0" indent="0" marL="0">
+              <a:buNone/>
+            </a:pPr>
+            <a:r>
+              <a:rPr/>
+              <a:t>Worflows supported by the strategy</a:t>
+            </a:r>
+          </a:p>
+        </p:txBody>
+      </p:sp>
+      <p:sp>
+        <p:nvSpPr>
+          <p:cNvPr id="4" name="Text Placeholder 3"/>
+          <p:cNvSpPr>
+            <a:spLocks noGrp="1"/>
+          </p:cNvSpPr>
+          <p:nvPr>
+            <p:ph idx="2" sz="half" type="body"/>
+          </p:nvPr>
+        </p:nvSpPr>
         <p:spPr/>
         <p:txBody>
           <a:bodyPr/>
@@ -4391,25 +4422,9 @@
             </a:pPr>
             <a:r>
               <a:rPr/>
-              <a:t>Worflows supported by the strategy</a:t>
-            </a:r>
-          </a:p>
-        </p:txBody>
-      </p:sp>
-      <p:sp>
-        <p:nvSpPr>
-          <p:cNvPr id="3" name="Content Placeholder 2"/>
-          <p:cNvSpPr>
-            <a:spLocks noGrp="1"/>
-          </p:cNvSpPr>
-          <p:nvPr>
-            <p:ph idx="1"/>
-          </p:nvPr>
-        </p:nvSpPr>
-        <p:spPr/>
-        <p:txBody>
-          <a:bodyPr/>
-          <a:lstStyle/>
+              <a:t>What do teams do?</a:t>
+            </a:r>
+          </a:p>
           <a:p>
             <a:pPr lvl="0" indent="0" marL="0">
               <a:spcBef>
@@ -4419,9 +4434,110 @@
             </a:pPr>
             <a:r>
               <a:rPr b="1"/>
+              <a:t>Three foundation workflows</a:t>
+            </a:r>
+          </a:p>
+          <a:p>
+            <a:pPr lvl="0"/>
+            <a:r>
+              <a:rPr/>
+              <a:t>Deliver changes with the next planned release</a:t>
+            </a:r>
+          </a:p>
+          <a:p>
+            <a:pPr lvl="0"/>
+            <a:r>
+              <a:rPr/>
+              <a:t>Implement a fix for the current production state</a:t>
+            </a:r>
+          </a:p>
+          <a:p>
+            <a:pPr lvl="0"/>
+            <a:r>
+              <a:rPr/>
+              <a:t>Use an epic branch for a significant development initiative</a:t>
+            </a:r>
+          </a:p>
+          <a:p>
+            <a:pPr lvl="0" indent="0" marL="0">
+              <a:spcBef>
+                <a:spcPts val="3000"/>
+              </a:spcBef>
+              <a:buNone/>
+            </a:pPr>
+            <a:r>
+              <a:rPr b="1"/>
               <a:t>Delivering changes via a release</a:t>
             </a:r>
           </a:p>
+        </p:txBody>
+      </p:sp>
+      <p:pic>
+        <p:nvPicPr>
+          <p:cNvPr descr="p1_files/figure-pptx/mermaid-figure-1.png" id="0" name="Picture 1"/>
+          <p:cNvPicPr>
+            <a:picLocks noGrp="1" noChangeAspect="1"/>
+          </p:cNvPicPr>
+          <p:nvPr/>
+        </p:nvPicPr>
+        <p:blipFill>
+          <a:blip r:embed="rId2"/>
+          <a:stretch>
+            <a:fillRect/>
+          </a:stretch>
+        </p:blipFill>
+        <p:spPr bwMode="auto">
+          <a:xfrm>
+            <a:off x="3568700" y="2184400"/>
+            <a:ext cx="5105400" cy="406400"/>
+          </a:xfrm>
+          <a:prstGeom prst="rect">
+            <a:avLst/>
+          </a:prstGeom>
+          <a:noFill/>
+          <a:ln w="9525">
+            <a:noFill/>
+            <a:headEnd/>
+            <a:tailEnd/>
+          </a:ln>
+        </p:spPr>
+      </p:pic>
+    </p:spTree>
+  </p:cSld>
+</p:sld>
+</file>
+
+<file path=ppt/slides/slide9.xml><?xml version="1.0" encoding="utf-8"?>
+<p:sld xmlns:a="http://schemas.openxmlformats.org/drawingml/2006/main" xmlns:r="http://schemas.openxmlformats.org/officeDocument/2006/relationships" xmlns:p="http://schemas.openxmlformats.org/presentationml/2006/main">
+  <p:cSld>
+    <p:spTree>
+      <p:nvGrpSpPr>
+        <p:cNvPr id="1" name=""/>
+        <p:cNvGrpSpPr/>
+        <p:nvPr/>
+      </p:nvGrpSpPr>
+      <p:grpSpPr>
+        <a:xfrm>
+          <a:off x="0" y="0"/>
+          <a:ext cx="0" cy="0"/>
+          <a:chOff x="0" y="0"/>
+          <a:chExt cx="0" cy="0"/>
+        </a:xfrm>
+      </p:grpSpPr>
+      <p:sp>
+        <p:nvSpPr>
+          <p:cNvPr id="3" name="Content Placeholder 2"/>
+          <p:cNvSpPr>
+            <a:spLocks noGrp="1"/>
+          </p:cNvSpPr>
+          <p:nvPr>
+            <p:ph idx="1"/>
+          </p:nvPr>
+        </p:nvSpPr>
+        <p:spPr/>
+        <p:txBody>
+          <a:bodyPr/>
+          <a:lstStyle/>
           <a:p>
             <a:pPr lvl="0" indent="0" marL="0">
               <a:spcBef>

</xml_diff>

<commit_message>
Split the merging chart in two plus other nits
</commit_message>
<xml_diff>
--- a/docs/p1.pptx
+++ b/docs/p1.pptx
@@ -17,6 +17,12 @@
     <p:sldId id="265" r:id="rId11"/>
     <p:sldId id="266" r:id="rId12"/>
     <p:sldId id="267" r:id="rId13"/>
+    <p:sldId id="268" r:id="rId14"/>
+    <p:sldId id="269" r:id="rId15"/>
+    <p:sldId id="270" r:id="rId16"/>
+    <p:sldId id="271" r:id="rId17"/>
+    <p:sldId id="272" r:id="rId18"/>
+    <p:sldId id="273" r:id="rId19"/>
   </p:sldIdLst>
   <p:sldSz cx="9144000" cy="5143500" type="screen16x9"/>
   <p:notesSz cx="6858000" cy="9144000"/>
@@ -3211,7 +3217,7 @@
             </a:pPr>
             <a:r>
               <a:rPr b="1"/>
-              <a:t>Release branches</a:t>
+              <a:t>Release maintenance branches</a:t>
             </a:r>
           </a:p>
           <a:p>
@@ -3484,7 +3490,12 @@
             <p:ph type="title"/>
           </p:nvPr>
         </p:nvSpPr>
-        <p:spPr/>
+        <p:spPr>
+          <a:xfrm>
+            <a:off x="457201" y="204787"/>
+            <a:ext cx="3008313" cy="871538"/>
+          </a:xfrm>
+        </p:spPr>
         <p:txBody>
           <a:bodyPr/>
           <a:lstStyle/>
@@ -3494,19 +3505,19 @@
             </a:pPr>
             <a:r>
               <a:rPr/>
-              <a:t>Worflows supported by the strategy</a:t>
-            </a:r>
-          </a:p>
-        </p:txBody>
-      </p:sp>
-      <p:sp>
-        <p:nvSpPr>
-          <p:cNvPr id="3" name="Content Placeholder 2"/>
-          <p:cNvSpPr>
-            <a:spLocks noGrp="1"/>
-          </p:cNvSpPr>
-          <p:nvPr>
-            <p:ph idx="1"/>
+              <a:t>Workflows supported by the strategy</a:t>
+            </a:r>
+          </a:p>
+        </p:txBody>
+      </p:sp>
+      <p:sp>
+        <p:nvSpPr>
+          <p:cNvPr id="4" name="Text Placeholder 3"/>
+          <p:cNvSpPr>
+            <a:spLocks noGrp="1"/>
+          </p:cNvSpPr>
+          <p:nvPr>
+            <p:ph idx="2" sz="half" type="body"/>
           </p:nvPr>
         </p:nvSpPr>
         <p:spPr/>
@@ -3522,7 +3533,60 @@
             </a:pPr>
             <a:r>
               <a:rPr b="1"/>
-              <a:t>Delivering changes via a release</a:t>
+              <a:t>The types of workflows</a:t>
+            </a:r>
+          </a:p>
+          <a:p>
+            <a:pPr lvl="0" indent="-342900" marL="342900">
+              <a:buAutoNum type="arabicParenR"/>
+            </a:pPr>
+            <a:r>
+              <a:rPr/>
+              <a:t>Work and focus on the </a:t>
+            </a:r>
+            <a:r>
+              <a:rPr b="1"/>
+              <a:t>next planned release</a:t>
+            </a:r>
+            <a:r>
+              <a:rPr/>
+              <a:t> via the </a:t>
+            </a:r>
+            <a:r>
+              <a:rPr>
+                <a:latin typeface="Courier"/>
+              </a:rPr>
+              <a:t>main</a:t>
+            </a:r>
+            <a:r>
+              <a:rPr/>
+              <a:t> branch. After planning the work items for the next release, the development team is adding changes to the main branch.</a:t>
+            </a:r>
+          </a:p>
+          <a:p>
+            <a:pPr lvl="0" indent="-342900" marL="342900">
+              <a:buAutoNum type="arabicParenR"/>
+            </a:pPr>
+            <a:r>
+              <a:rPr b="1"/>
+              <a:t>Resolution of a production problem</a:t>
+            </a:r>
+            <a:r>
+              <a:rPr/>
+              <a:t> in the currently-released version of the application by leveraging a release maintenance branch that is used for maintenance purposes,</a:t>
+            </a:r>
+          </a:p>
+          <a:p>
+            <a:pPr lvl="0" indent="-342900" marL="342900">
+              <a:buAutoNum type="arabicParenR"/>
+            </a:pPr>
+            <a:r>
+              <a:rPr b="1"/>
+              <a:t>concurrent development activities for significant development initiatives</a:t>
+            </a:r>
+            <a:r>
+              <a:rPr/>
+              <a:t>, which include multiple planned work items for a later delivery (including starting development of a future release) by creating an epic branch from a commit point in the history of main.</a:t>
             </a:r>
           </a:p>
           <a:p>
@@ -3538,6 +3602,96 @@
             </a:r>
           </a:p>
           <a:p>
+            <a:pPr lvl="0"/>
+            <a:r>
+              <a:rPr/>
+              <a:t>The process of urgent fixes for modules in the production environment follows the fix-forward approach, rather than rolling back the affected modules and reverting to the previous deployed state.</a:t>
+            </a:r>
+          </a:p>
+          <a:p>
+            <a:pPr lvl="0"/>
+            <a:r>
+              <a:rPr/>
+              <a:t>The development team starts this process by creating a </a:t>
+            </a:r>
+            <a:r>
+              <a:rPr b="1"/>
+              <a:t>release maintenance</a:t>
+            </a:r>
+            <a:r>
+              <a:rPr/>
+              <a:t> branch of the git tag that represents the most recent release, that was deployed to production.</a:t>
+            </a:r>
+          </a:p>
+        </p:txBody>
+      </p:sp>
+      <p:pic>
+        <p:nvPicPr>
+          <p:cNvPr descr="static/img/branching-model/releaseMaintenanceWorkflow_overview.png" id="0" name="Picture 1"/>
+          <p:cNvPicPr>
+            <a:picLocks noGrp="1" noChangeAspect="1"/>
+          </p:cNvPicPr>
+          <p:nvPr/>
+        </p:nvPicPr>
+        <p:blipFill>
+          <a:blip r:embed="rId2"/>
+          <a:stretch>
+            <a:fillRect/>
+          </a:stretch>
+        </p:blipFill>
+        <p:spPr bwMode="auto">
+          <a:xfrm>
+            <a:off x="4000500" y="203200"/>
+            <a:ext cx="4241800" cy="4381500"/>
+          </a:xfrm>
+          <a:prstGeom prst="rect">
+            <a:avLst/>
+          </a:prstGeom>
+          <a:noFill/>
+          <a:ln w="9525">
+            <a:noFill/>
+            <a:headEnd/>
+            <a:tailEnd/>
+          </a:ln>
+        </p:spPr>
+      </p:pic>
+    </p:spTree>
+  </p:cSld>
+</p:sld>
+</file>
+
+<file path=ppt/slides/slide13.xml><?xml version="1.0" encoding="utf-8"?>
+<p:sld xmlns:a="http://schemas.openxmlformats.org/drawingml/2006/main" xmlns:r="http://schemas.openxmlformats.org/officeDocument/2006/relationships" xmlns:p="http://schemas.openxmlformats.org/presentationml/2006/main">
+  <p:cSld>
+    <p:spTree>
+      <p:nvGrpSpPr>
+        <p:cNvPr id="1" name=""/>
+        <p:cNvGrpSpPr/>
+        <p:nvPr/>
+      </p:nvGrpSpPr>
+      <p:grpSpPr>
+        <a:xfrm>
+          <a:off x="0" y="0"/>
+          <a:ext cx="0" cy="0"/>
+          <a:chOff x="0" y="0"/>
+          <a:chExt cx="0" cy="0"/>
+        </a:xfrm>
+      </p:grpSpPr>
+      <p:sp>
+        <p:nvSpPr>
+          <p:cNvPr id="4" name="Text Placeholder 3"/>
+          <p:cNvSpPr>
+            <a:spLocks noGrp="1"/>
+          </p:cNvSpPr>
+          <p:nvPr>
+            <p:ph idx="2" sz="half" type="body"/>
+          </p:nvPr>
+        </p:nvSpPr>
+        <p:spPr/>
+        <p:txBody>
+          <a:bodyPr/>
+          <a:lstStyle/>
+          <a:p>
             <a:pPr lvl="0" indent="0" marL="0">
               <a:spcBef>
                 <a:spcPts val="3000"/>
@@ -3546,7 +3700,580 @@
             </a:pPr>
             <a:r>
               <a:rPr b="1"/>
-              <a:t>Using an Epic branch</a:t>
+              <a:t>Building the fix package</a:t>
+            </a:r>
+          </a:p>
+          <a:p>
+            <a:pPr lvl="0"/>
+            <a:r>
+              <a:rPr/>
+              <a:t>Changes contributed to the release maintenance branch are build and packaged.</a:t>
+            </a:r>
+          </a:p>
+          <a:p>
+            <a:pPr lvl="0"/>
+            <a:r>
+              <a:rPr/>
+              <a:t>The fix package is tested in the appropriate test env</a:t>
+            </a:r>
+          </a:p>
+          <a:p>
+            <a:pPr lvl="0"/>
+            <a:r>
+              <a:rPr/>
+              <a:t>Finally deployed to production</a:t>
+            </a:r>
+          </a:p>
+        </p:txBody>
+      </p:sp>
+      <p:pic>
+        <p:nvPicPr>
+          <p:cNvPr descr="static/img/branching-model/releaseMaintenanceWorkflow_fixPackageBuild.png" id="0" name="Picture 1"/>
+          <p:cNvPicPr>
+            <a:picLocks noGrp="1" noChangeAspect="1"/>
+          </p:cNvPicPr>
+          <p:nvPr/>
+        </p:nvPicPr>
+        <p:blipFill>
+          <a:blip r:embed="rId2"/>
+          <a:stretch>
+            <a:fillRect/>
+          </a:stretch>
+        </p:blipFill>
+        <p:spPr bwMode="auto">
+          <a:xfrm>
+            <a:off x="3568700" y="355600"/>
+            <a:ext cx="5105400" cy="4064000"/>
+          </a:xfrm>
+          <a:prstGeom prst="rect">
+            <a:avLst/>
+          </a:prstGeom>
+          <a:noFill/>
+          <a:ln w="9525">
+            <a:noFill/>
+            <a:headEnd/>
+            <a:tailEnd/>
+          </a:ln>
+        </p:spPr>
+      </p:pic>
+    </p:spTree>
+  </p:cSld>
+</p:sld>
+</file>
+
+<file path=ppt/slides/slide14.xml><?xml version="1.0" encoding="utf-8"?>
+<p:sld xmlns:a="http://schemas.openxmlformats.org/drawingml/2006/main" xmlns:r="http://schemas.openxmlformats.org/officeDocument/2006/relationships" xmlns:p="http://schemas.openxmlformats.org/presentationml/2006/main">
+  <p:cSld>
+    <p:spTree>
+      <p:nvGrpSpPr>
+        <p:cNvPr id="1" name=""/>
+        <p:cNvGrpSpPr/>
+        <p:nvPr/>
+      </p:nvGrpSpPr>
+      <p:grpSpPr>
+        <a:xfrm>
+          <a:off x="0" y="0"/>
+          <a:ext cx="0" cy="0"/>
+          <a:chOff x="0" y="0"/>
+          <a:chExt cx="0" cy="0"/>
+        </a:xfrm>
+      </p:grpSpPr>
+      <p:sp>
+        <p:nvSpPr>
+          <p:cNvPr id="4" name="Text Placeholder 3"/>
+          <p:cNvSpPr>
+            <a:spLocks noGrp="1"/>
+          </p:cNvSpPr>
+          <p:nvPr>
+            <p:ph idx="2" sz="half" type="body"/>
+          </p:nvPr>
+        </p:nvSpPr>
+        <p:spPr/>
+        <p:txBody>
+          <a:bodyPr/>
+          <a:lstStyle/>
+          <a:p>
+            <a:pPr lvl="0"/>
+            <a:r>
+              <a:rPr/>
+              <a:t>The commit is tagged as the new version </a:t>
+            </a:r>
+            <a:r>
+              <a:rPr>
+                <a:latin typeface="Courier"/>
+              </a:rPr>
+              <a:t>2.1.1</a:t>
+            </a:r>
+            <a:r>
+              <a:rPr/>
+              <a:t>.</a:t>
+            </a:r>
+          </a:p>
+          <a:p>
+            <a:pPr lvl="0" indent="0" marL="0">
+              <a:spcBef>
+                <a:spcPts val="3000"/>
+              </a:spcBef>
+              <a:buNone/>
+            </a:pPr>
+            <a:r>
+              <a:rPr b="1"/>
+              <a:t>Using the Epic branch workflow</a:t>
+            </a:r>
+          </a:p>
+          <a:p>
+            <a:pPr lvl="0" indent="0" marL="0">
+              <a:buNone/>
+            </a:pPr>
+            <a:r>
+              <a:rPr/>
+              <a:t>Dealing with significant development initiatives like</a:t>
+            </a:r>
+          </a:p>
+          <a:p>
+            <a:pPr lvl="0"/>
+            <a:r>
+              <a:rPr/>
+              <a:t>Updates in regulatory frameworks</a:t>
+            </a:r>
+          </a:p>
+          <a:p>
+            <a:pPr lvl="0"/>
+            <a:r>
+              <a:rPr/>
+              <a:t>Start the development phase of </a:t>
+            </a:r>
+            <a:r>
+              <a:rPr i="1"/>
+              <a:t>subsequent</a:t>
+            </a:r>
+            <a:r>
+              <a:rPr/>
+              <a:t> releases</a:t>
+            </a:r>
+          </a:p>
+          <a:p>
+            <a:pPr lvl="0" indent="0" marL="0">
+              <a:buNone/>
+            </a:pPr>
+            <a:r>
+              <a:rPr/>
+              <a:t>-&gt; A process to work independently from the default workflow.</a:t>
+            </a:r>
+          </a:p>
+          <a:p>
+            <a:pPr lvl="0" indent="0" marL="0">
+              <a:spcBef>
+                <a:spcPts val="3000"/>
+              </a:spcBef>
+              <a:buNone/>
+            </a:pPr>
+            <a:r>
+              <a:rPr b="1"/>
+              <a:t>Epic branch workflow</a:t>
+            </a:r>
+          </a:p>
+        </p:txBody>
+      </p:sp>
+      <p:pic>
+        <p:nvPicPr>
+          <p:cNvPr descr="static/img/branching-model/image12.png" id="0" name="Picture 1"/>
+          <p:cNvPicPr>
+            <a:picLocks noGrp="1" noChangeAspect="1"/>
+          </p:cNvPicPr>
+          <p:nvPr/>
+        </p:nvPicPr>
+        <p:blipFill>
+          <a:blip r:embed="rId2"/>
+          <a:stretch>
+            <a:fillRect/>
+          </a:stretch>
+        </p:blipFill>
+        <p:spPr bwMode="auto">
+          <a:xfrm>
+            <a:off x="3568700" y="1244600"/>
+            <a:ext cx="5105400" cy="2311400"/>
+          </a:xfrm>
+          <a:prstGeom prst="rect">
+            <a:avLst/>
+          </a:prstGeom>
+          <a:noFill/>
+          <a:ln w="9525">
+            <a:noFill/>
+            <a:headEnd/>
+            <a:tailEnd/>
+          </a:ln>
+        </p:spPr>
+      </p:pic>
+    </p:spTree>
+  </p:cSld>
+</p:sld>
+</file>
+
+<file path=ppt/slides/slide15.xml><?xml version="1.0" encoding="utf-8"?>
+<p:sld xmlns:a="http://schemas.openxmlformats.org/drawingml/2006/main" xmlns:r="http://schemas.openxmlformats.org/officeDocument/2006/relationships" xmlns:p="http://schemas.openxmlformats.org/presentationml/2006/main">
+  <p:cSld>
+    <p:spTree>
+      <p:nvGrpSpPr>
+        <p:cNvPr id="1" name=""/>
+        <p:cNvGrpSpPr/>
+        <p:nvPr/>
+      </p:nvGrpSpPr>
+      <p:grpSpPr>
+        <a:xfrm>
+          <a:off x="0" y="0"/>
+          <a:ext cx="0" cy="0"/>
+          <a:chOff x="0" y="0"/>
+          <a:chExt cx="0" cy="0"/>
+        </a:xfrm>
+      </p:grpSpPr>
+      <p:sp>
+        <p:nvSpPr>
+          <p:cNvPr id="3" name="Content Placeholder 2"/>
+          <p:cNvSpPr>
+            <a:spLocks noGrp="1"/>
+          </p:cNvSpPr>
+          <p:nvPr>
+            <p:ph idx="1"/>
+          </p:nvPr>
+        </p:nvSpPr>
+        <p:spPr/>
+        <p:txBody>
+          <a:bodyPr/>
+          <a:lstStyle/>
+          <a:p>
+            <a:pPr lvl="0" indent="0" marL="0">
+              <a:spcBef>
+                <a:spcPts val="3000"/>
+              </a:spcBef>
+              <a:buNone/>
+            </a:pPr>
+            <a:r>
+              <a:rPr b="1"/>
+              <a:t>Guidelines and policies in the epic branch workflow</a:t>
+            </a:r>
+          </a:p>
+          <a:p>
+            <a:pPr lvl="0"/>
+            <a:r>
+              <a:rPr/>
+              <a:t>Frequently merge updates from </a:t>
+            </a:r>
+            <a:r>
+              <a:rPr>
+                <a:latin typeface="Courier"/>
+              </a:rPr>
+              <a:t>main</a:t>
+            </a:r>
+            <a:r>
+              <a:rPr/>
+              <a:t> into the epic branch to avoid making the merge of the </a:t>
+            </a:r>
+            <a:r>
+              <a:rPr>
+                <a:latin typeface="Courier"/>
+              </a:rPr>
+              <a:t>epic</a:t>
+            </a:r>
+            <a:r>
+              <a:rPr/>
+              <a:t> branch into </a:t>
+            </a:r>
+            <a:r>
+              <a:rPr>
+                <a:latin typeface="Courier"/>
+              </a:rPr>
+              <a:t>main</a:t>
+            </a:r>
+            <a:r>
+              <a:rPr/>
+              <a:t> difficult.</a:t>
+            </a:r>
+          </a:p>
+          <a:p>
+            <a:pPr lvl="0"/>
+            <a:r>
+              <a:rPr/>
+              <a:t>Preliminary packages must not be deployed to a production runtime.</a:t>
+            </a:r>
+          </a:p>
+        </p:txBody>
+      </p:sp>
+    </p:spTree>
+  </p:cSld>
+</p:sld>
+</file>
+
+<file path=ppt/slides/slide16.xml><?xml version="1.0" encoding="utf-8"?>
+<p:sld xmlns:a="http://schemas.openxmlformats.org/drawingml/2006/main" xmlns:r="http://schemas.openxmlformats.org/officeDocument/2006/relationships" xmlns:p="http://schemas.openxmlformats.org/presentationml/2006/main">
+  <p:cSld>
+    <p:spTree>
+      <p:nvGrpSpPr>
+        <p:cNvPr id="1" name=""/>
+        <p:cNvGrpSpPr/>
+        <p:nvPr/>
+      </p:nvGrpSpPr>
+      <p:grpSpPr>
+        <a:xfrm>
+          <a:off x="0" y="0"/>
+          <a:ext cx="0" cy="0"/>
+          <a:chOff x="0" y="0"/>
+          <a:chExt cx="0" cy="0"/>
+        </a:xfrm>
+      </p:grpSpPr>
+      <p:sp>
+        <p:nvSpPr>
+          <p:cNvPr id="2" name="Title 1"/>
+          <p:cNvSpPr>
+            <a:spLocks noGrp="1"/>
+          </p:cNvSpPr>
+          <p:nvPr>
+            <p:ph type="title"/>
+          </p:nvPr>
+        </p:nvSpPr>
+        <p:spPr>
+          <a:xfrm>
+            <a:off x="457201" y="204787"/>
+            <a:ext cx="3008313" cy="871538"/>
+          </a:xfrm>
+        </p:spPr>
+        <p:txBody>
+          <a:bodyPr/>
+          <a:lstStyle/>
+          <a:p>
+            <a:pPr lvl="0" indent="0" marL="0">
+              <a:buNone/>
+            </a:pPr>
+            <a:r>
+              <a:rPr/>
+              <a:t>Pipeline implementations</a:t>
+            </a:r>
+          </a:p>
+        </p:txBody>
+      </p:sp>
+      <p:sp>
+        <p:nvSpPr>
+          <p:cNvPr id="4" name="Text Placeholder 3"/>
+          <p:cNvSpPr>
+            <a:spLocks noGrp="1"/>
+          </p:cNvSpPr>
+          <p:nvPr>
+            <p:ph idx="2" sz="half" type="body"/>
+          </p:nvPr>
+        </p:nvSpPr>
+        <p:spPr/>
+        <p:txBody>
+          <a:bodyPr/>
+          <a:lstStyle/>
+          <a:p>
+            <a:pPr lvl="0" indent="0" marL="0">
+              <a:spcBef>
+                <a:spcPts val="3000"/>
+              </a:spcBef>
+              <a:buNone/>
+            </a:pPr>
+            <a:r>
+              <a:rPr b="1"/>
+              <a:t>Pipeline principles</a:t>
+            </a:r>
+          </a:p>
+          <a:p>
+            <a:pPr lvl="0" indent="0" marL="0">
+              <a:buNone/>
+            </a:pPr>
+            <a:r>
+              <a:rPr/>
+              <a:t>Git tags are leveraged to calculate the changes for the next planned release</a:t>
+            </a:r>
+          </a:p>
+        </p:txBody>
+      </p:sp>
+      <p:pic>
+        <p:nvPicPr>
+          <p:cNvPr descr="static/img/branching-model/basicBuildPipeline-computeChanges-default-workflow.png" id="0" name="Picture 1"/>
+          <p:cNvPicPr>
+            <a:picLocks noGrp="1" noChangeAspect="1"/>
+          </p:cNvPicPr>
+          <p:nvPr/>
+        </p:nvPicPr>
+        <p:blipFill>
+          <a:blip r:embed="rId2"/>
+          <a:stretch>
+            <a:fillRect/>
+          </a:stretch>
+        </p:blipFill>
+        <p:spPr bwMode="auto">
+          <a:xfrm>
+            <a:off x="3568700" y="1066800"/>
+            <a:ext cx="5105400" cy="2641600"/>
+          </a:xfrm>
+          <a:prstGeom prst="rect">
+            <a:avLst/>
+          </a:prstGeom>
+          <a:noFill/>
+          <a:ln w="9525">
+            <a:noFill/>
+            <a:headEnd/>
+            <a:tailEnd/>
+          </a:ln>
+        </p:spPr>
+      </p:pic>
+    </p:spTree>
+  </p:cSld>
+</p:sld>
+</file>
+
+<file path=ppt/slides/slide17.xml><?xml version="1.0" encoding="utf-8"?>
+<p:sld xmlns:a="http://schemas.openxmlformats.org/drawingml/2006/main" xmlns:r="http://schemas.openxmlformats.org/officeDocument/2006/relationships" xmlns:p="http://schemas.openxmlformats.org/presentationml/2006/main">
+  <p:cSld>
+    <p:spTree>
+      <p:nvGrpSpPr>
+        <p:cNvPr id="1" name=""/>
+        <p:cNvGrpSpPr/>
+        <p:nvPr/>
+      </p:nvGrpSpPr>
+      <p:grpSpPr>
+        <a:xfrm>
+          <a:off x="0" y="0"/>
+          <a:ext cx="0" cy="0"/>
+          <a:chOff x="0" y="0"/>
+          <a:chExt cx="0" cy="0"/>
+        </a:xfrm>
+      </p:grpSpPr>
+      <p:sp>
+        <p:nvSpPr>
+          <p:cNvPr id="3" name="Content Placeholder 2"/>
+          <p:cNvSpPr>
+            <a:spLocks noGrp="1"/>
+          </p:cNvSpPr>
+          <p:nvPr>
+            <p:ph idx="1"/>
+          </p:nvPr>
+        </p:nvSpPr>
+        <p:spPr/>
+        <p:txBody>
+          <a:bodyPr/>
+          <a:lstStyle/>
+          <a:p>
+            <a:pPr lvl="0" indent="0" marL="0">
+              <a:buNone/>
+            </a:pPr>
+            <a:r>
+              <a:rPr/>
+              <a:t>Packages are always cumulative.</a:t>
+            </a:r>
+          </a:p>
+          <a:p>
+            <a:pPr lvl="0" indent="0" marL="0">
+              <a:spcBef>
+                <a:spcPts val="3000"/>
+              </a:spcBef>
+              <a:buNone/>
+            </a:pPr>
+            <a:r>
+              <a:rPr b="1"/>
+              <a:t>Basic Build pipeline</a:t>
+            </a:r>
+          </a:p>
+          <a:p>
+            <a:pPr lvl="0"/>
+            <a:r>
+              <a:rPr/>
+              <a:t>(Typically) runs on each commit added to the history of a branch</a:t>
+            </a:r>
+          </a:p>
+          <a:p>
+            <a:pPr lvl="0"/>
+            <a:r>
+              <a:rPr/>
+              <a:t>Produces a preliminary package that is stored in a binary repository</a:t>
+            </a:r>
+          </a:p>
+          <a:p>
+            <a:pPr lvl="0"/>
+            <a:r>
+              <a:rPr/>
+              <a:t>May include an automated step to install it into the DEV-TEST environment</a:t>
+            </a:r>
+          </a:p>
+          <a:p>
+            <a:pPr lvl="0" indent="0" marL="0">
+              <a:spcBef>
+                <a:spcPts val="3000"/>
+              </a:spcBef>
+              <a:buNone/>
+            </a:pPr>
+            <a:r>
+              <a:rPr b="1"/>
+              <a:t>Release Pipeline</a:t>
+            </a:r>
+          </a:p>
+          <a:p>
+            <a:pPr lvl="0"/>
+            <a:r>
+              <a:rPr/>
+              <a:t>Produces binaries optimized for performance</a:t>
+            </a:r>
+          </a:p>
+          <a:p>
+            <a:pPr lvl="0"/>
+            <a:r>
+              <a:rPr/>
+              <a:t>(Typically) is manually requested by the development team when a level of stability is reached</a:t>
+            </a:r>
+          </a:p>
+          <a:p>
+            <a:pPr lvl="0"/>
+            <a:r>
+              <a:rPr/>
+              <a:t>produces a release candidate package that can be deployed to higher test environments.</a:t>
+            </a:r>
+          </a:p>
+        </p:txBody>
+      </p:sp>
+    </p:spTree>
+  </p:cSld>
+</p:sld>
+</file>
+
+<file path=ppt/slides/slide18.xml><?xml version="1.0" encoding="utf-8"?>
+<p:sld xmlns:a="http://schemas.openxmlformats.org/drawingml/2006/main" xmlns:r="http://schemas.openxmlformats.org/officeDocument/2006/relationships" xmlns:p="http://schemas.openxmlformats.org/presentationml/2006/main">
+  <p:cSld>
+    <p:spTree>
+      <p:nvGrpSpPr>
+        <p:cNvPr id="1" name=""/>
+        <p:cNvGrpSpPr/>
+        <p:nvPr/>
+      </p:nvGrpSpPr>
+      <p:grpSpPr>
+        <a:xfrm>
+          <a:off x="0" y="0"/>
+          <a:ext cx="0" cy="0"/>
+          <a:chOff x="0" y="0"/>
+          <a:chExt cx="0" cy="0"/>
+        </a:xfrm>
+      </p:grpSpPr>
+      <p:sp>
+        <p:nvSpPr>
+          <p:cNvPr id="2" name="Title 1"/>
+          <p:cNvSpPr>
+            <a:spLocks noGrp="1"/>
+          </p:cNvSpPr>
+          <p:nvPr>
+            <p:ph type="title"/>
+          </p:nvPr>
+        </p:nvSpPr>
+        <p:spPr/>
+        <p:txBody>
+          <a:bodyPr/>
+          <a:lstStyle/>
+          <a:p>
+            <a:pPr lvl="0" indent="0" marL="0">
+              <a:buNone/>
+            </a:pPr>
+            <a:r>
+              <a:rPr/>
+              <a:t>Collateral</a:t>
             </a:r>
           </a:p>
         </p:txBody>
@@ -3610,49 +4337,21 @@
             <a:pPr lvl="0"/>
             <a:r>
               <a:rPr/>
-              <a:t>Choosing a branching model and workflow</a:t>
-            </a:r>
-          </a:p>
-          <a:p>
-            <a:pPr lvl="0"/>
-            <a:r>
-              <a:rPr/>
-              <a:t>Starting simple</a:t>
-            </a:r>
-          </a:p>
-          <a:p>
-            <a:pPr lvl="0"/>
-            <a:r>
-              <a:rPr/>
-              <a:t>Scaling up</a:t>
-            </a:r>
-          </a:p>
-          <a:p>
-            <a:pPr lvl="0"/>
-            <a:r>
-              <a:rPr/>
-              <a:t>Integration branches</a:t>
-            </a:r>
-          </a:p>
-          <a:p>
-            <a:pPr lvl="0"/>
-            <a:r>
-              <a:rPr/>
-              <a:t>Delivering changes via a release</a:t>
-            </a:r>
-          </a:p>
-          <a:p>
-            <a:pPr lvl="0"/>
-            <a:r>
-              <a:rPr/>
-              <a:t>Hot-fix for production</a:t>
-            </a:r>
-          </a:p>
-          <a:p>
-            <a:pPr lvl="0"/>
-            <a:r>
-              <a:rPr/>
-              <a:t>Using an Epic branch</a:t>
+              <a:t>Fundamentals of the branching strategy</a:t>
+            </a:r>
+          </a:p>
+          <a:p>
+            <a:pPr lvl="0"/>
+            <a:r>
+              <a:rPr/>
+              <a:t>Supported workflows</a:t>
+            </a:r>
+          </a:p>
+          <a:p>
+            <a:pPr lvl="0"/>
+            <a:r>
+              <a:rPr/>
+              <a:t>Implementing pipelines</a:t>
             </a:r>
           </a:p>
         </p:txBody>
@@ -4221,7 +4920,7 @@
             </a:pPr>
             <a:r>
               <a:rPr b="1"/>
-              <a:t>Merging into </a:t>
+              <a:t>Preparing to Merge into </a:t>
             </a:r>
             <a:r>
               <a:rPr b="1">
@@ -4352,6 +5051,24 @@
           <a:lstStyle/>
           <a:p>
             <a:pPr lvl="0" indent="0" marL="0">
+              <a:spcBef>
+                <a:spcPts val="3000"/>
+              </a:spcBef>
+              <a:buNone/>
+            </a:pPr>
+            <a:r>
+              <a:rPr b="1"/>
+              <a:t>Merging into </a:t>
+            </a:r>
+            <a:r>
+              <a:rPr b="1">
+                <a:latin typeface="Courier"/>
+              </a:rPr>
+              <a:t>main</a:t>
+            </a:r>
+          </a:p>
+          <a:p>
+            <a:pPr lvl="0" indent="0" marL="0">
               <a:buNone/>
             </a:pPr>
             <a:r>
@@ -4461,6 +5178,49 @@
         <p:txBody>
           <a:bodyPr/>
           <a:lstStyle/>
+          <a:p>
+            <a:pPr lvl="0" indent="0" marL="0">
+              <a:buNone/>
+            </a:pPr>
+            <a:r>
+              <a:rPr>
+                <a:latin typeface="Courier"/>
+              </a:rPr>
+              <a:t>main</a:t>
+            </a:r>
+            <a:r>
+              <a:rPr/>
+              <a:t> and other long-lived branches are </a:t>
+            </a:r>
+            <a:r>
+              <a:rPr i="1"/>
+              <a:t>protected</a:t>
+            </a:r>
+            <a:r>
+              <a:rPr/>
+              <a:t> (not everyone can </a:t>
+            </a:r>
+            <a:r>
+              <a:rPr>
+                <a:latin typeface="Courier"/>
+              </a:rPr>
+              <a:t>push</a:t>
+            </a:r>
+            <a:r>
+              <a:rPr/>
+              <a:t> or </a:t>
+            </a:r>
+            <a:r>
+              <a:rPr>
+                <a:latin typeface="Courier"/>
+              </a:rPr>
+              <a:t>merge</a:t>
+            </a:r>
+            <a:r>
+              <a:rPr/>
+              <a:t> to them).</a:t>
+            </a:r>
+          </a:p>
           <a:p>
             <a:pPr lvl="0" indent="0" marL="0">
               <a:spcBef>

</xml_diff>

<commit_message>
Add slide numbers and proper right arrow
</commit_message>
<xml_diff>
--- a/docs/p1.pptx
+++ b/docs/p1.pptx
@@ -3526,6 +3526,15 @@
           <a:lstStyle/>
           <a:p>
             <a:pPr lvl="0" indent="0" marL="0">
+              <a:buNone/>
+            </a:pPr>
+            <a:r>
+              <a:rPr/>
+              <a:t>How do teams work with and benefit from the branch strategy?</a:t>
+            </a:r>
+          </a:p>
+          <a:p>
+            <a:pPr lvl="0" indent="0" marL="0">
               <a:spcBef>
                 <a:spcPts val="3000"/>
               </a:spcBef>
@@ -3587,6 +3596,27 @@
             <a:r>
               <a:rPr/>
               <a:t>, which include multiple planned work items for a later delivery (including starting development of a future release) by creating an epic branch from a commit point in the history of main.</a:t>
+            </a:r>
+          </a:p>
+          <a:p>
+            <a:pPr lvl="0" indent="0" marL="0">
+              <a:spcBef>
+                <a:spcPts val="3000"/>
+              </a:spcBef>
+              <a:buNone/>
+            </a:pPr>
+            <a:r>
+              <a:rPr b="1"/>
+              <a:t>Features for the next planned release</a:t>
+            </a:r>
+          </a:p>
+          <a:p>
+            <a:pPr lvl="0" indent="0" marL="0">
+              <a:buNone/>
+            </a:pPr>
+            <a:r>
+              <a:rPr i="1"/>
+              <a:t>TO-DO</a:t>
             </a:r>
           </a:p>
           <a:p>
@@ -3714,7 +3744,7 @@
             <a:pPr lvl="0"/>
             <a:r>
               <a:rPr/>
-              <a:t>The fix package is tested in the appropriate test env</a:t>
+              <a:t>The fix package is tested in the appropriate test environment(s)</a:t>
             </a:r>
           </a:p>
           <a:p>
@@ -3827,7 +3857,7 @@
             </a:pPr>
             <a:r>
               <a:rPr/>
-              <a:t>Dealing with significant development initiatives like</a:t>
+              <a:t>Dealing with significant development initiatives such as:</a:t>
             </a:r>
           </a:p>
           <a:p>
@@ -3858,7 +3888,7 @@
             </a:pPr>
             <a:r>
               <a:rPr/>
-              <a:t>-&gt; A process to work independently from the default workflow.</a:t>
+              <a:t>→ A process to work independently from the default workflow.</a:t>
             </a:r>
           </a:p>
           <a:p>
@@ -3957,7 +3987,7 @@
             <a:pPr lvl="0"/>
             <a:r>
               <a:rPr/>
-              <a:t>Frequently merge updates from </a:t>
+              <a:t>Frequently synchronize with </a:t>
             </a:r>
             <a:r>
               <a:rPr>
@@ -4083,7 +4113,7 @@
             </a:pPr>
             <a:r>
               <a:rPr/>
-              <a:t>Git tags are leveraged to calculate the changes for the next planned release</a:t>
+              <a:t>Git tags are used to calculate the changes for the next planned release</a:t>
             </a:r>
           </a:p>
         </p:txBody>
@@ -4205,7 +4235,7 @@
             </a:pPr>
             <a:r>
               <a:rPr b="1"/>
-              <a:t>Release Pipeline</a:t>
+              <a:t>Release pipeline</a:t>
             </a:r>
           </a:p>
           <a:p>
@@ -4522,6 +4552,21 @@
             <a:r>
               <a:rPr/>
               <a:t>For each user’s experience</a:t>
+            </a:r>
+          </a:p>
+          <a:p>
+            <a:pPr lvl="0"/>
+            <a:r>
+              <a:rPr/>
+              <a:t>Be </a:t>
+            </a:r>
+            <a:r>
+              <a:rPr i="1"/>
+              <a:t>git-native</a:t>
+            </a:r>
+            <a:r>
+              <a:rPr/>
+              <a:t>!</a:t>
             </a:r>
           </a:p>
           <a:p>
@@ -5230,7 +5275,7 @@
             </a:pPr>
             <a:r>
               <a:rPr b="1"/>
-              <a:t>Before you ask… no, no </a:t>
+              <a:t>Before you ask… no, there is no </a:t>
             </a:r>
             <a:r>
               <a:rPr b="1" i="1"/>

</xml_diff>

<commit_message>
Add narrative for release development workflow
</commit_message>
<xml_diff>
--- a/docs/p1.pptx
+++ b/docs/p1.pptx
@@ -4223,7 +4223,7 @@
             <a:pPr lvl="0"/>
             <a:r>
               <a:rPr/>
-              <a:t>May include an automated step to install it into the DEV-TEST environment</a:t>
+              <a:t>May include an automated step to deploy it into the DEV-TEST environment</a:t>
             </a:r>
           </a:p>
           <a:p>
@@ -4256,7 +4256,7 @@
             <a:pPr lvl="0"/>
             <a:r>
               <a:rPr/>
-              <a:t>produces a release candidate package that can be deployed to higher test environments.</a:t>
+              <a:t>Produces a release candidate package that can be deployed to higher test environments.</a:t>
             </a:r>
           </a:p>
         </p:txBody>
@@ -4509,6 +4509,21 @@
             </a:r>
           </a:p>
           <a:p>
+            <a:pPr lvl="1"/>
+            <a:r>
+              <a:rPr/>
+              <a:t>Aim to be </a:t>
+            </a:r>
+            <a:r>
+              <a:rPr i="1"/>
+              <a:t>git-native</a:t>
+            </a:r>
+            <a:r>
+              <a:rPr/>
+              <a:t>!</a:t>
+            </a:r>
+          </a:p>
+          <a:p>
             <a:pPr lvl="0"/>
             <a:r>
               <a:rPr/>
@@ -4552,21 +4567,6 @@
             <a:r>
               <a:rPr/>
               <a:t>For each user’s experience</a:t>
-            </a:r>
-          </a:p>
-          <a:p>
-            <a:pPr lvl="0"/>
-            <a:r>
-              <a:rPr/>
-              <a:t>Be </a:t>
-            </a:r>
-            <a:r>
-              <a:rPr i="1"/>
-              <a:t>git-native</a:t>
-            </a:r>
-            <a:r>
-              <a:rPr/>
-              <a:t>!</a:t>
             </a:r>
           </a:p>
           <a:p>
@@ -4647,6 +4647,18 @@
             <a:r>
               <a:rPr/>
               <a:t>We know it is sometimes unavoidable for work to take longer than one release cycle and we accommodate that as a variant of the base workflow.</a:t>
+            </a:r>
+          </a:p>
+          <a:p>
+            <a:pPr lvl="0" indent="0" marL="0">
+              <a:spcBef>
+                <a:spcPts val="3000"/>
+              </a:spcBef>
+              <a:buNone/>
+            </a:pPr>
+            <a:r>
+              <a:rPr b="1"/>
+              <a:t>Convention over configuration</a:t>
             </a:r>
           </a:p>
         </p:txBody>

</xml_diff>

<commit_message>
Change pre and code css background-color for revealjs
</commit_message>
<xml_diff>
--- a/docs/p1.pptx
+++ b/docs/p1.pptx
@@ -5161,6 +5161,17 @@
               <a:t>Implementing pipelines</a:t>
             </a:r>
           </a:p>
+          <a:p>
+            <a:pPr lvl="0" indent="0">
+              <a:buNone/>
+            </a:pPr>
+            <a:r>
+              <a:rPr>
+                <a:latin typeface="Courier"/>
+              </a:rPr>
+              <a:t>some code</a:t>
+            </a:r>
+          </a:p>
         </p:txBody>
       </p:sp>
     </p:spTree>

</xml_diff>

<commit_message>
Build for enablement session
</commit_message>
<xml_diff>
--- a/docs/p1.pptx
+++ b/docs/p1.pptx
@@ -22,7 +22,6 @@
     <p:sldId id="270" r:id="rId16"/>
     <p:sldId id="271" r:id="rId17"/>
     <p:sldId id="272" r:id="rId18"/>
-    <p:sldId id="273" r:id="rId19"/>
   </p:sldIdLst>
   <p:sldSz cx="9144000" cy="5143500" type="screen16x9"/>
   <p:notesSz cx="6858000" cy="9144000"/>
@@ -3482,6 +3481,161 @@
       </p:grpSpPr>
       <p:sp>
         <p:nvSpPr>
+          <p:cNvPr id="3" name="Content Placeholder 2"/>
+          <p:cNvSpPr>
+            <a:spLocks noGrp="1"/>
+          </p:cNvSpPr>
+          <p:nvPr>
+            <p:ph idx="1"/>
+          </p:nvPr>
+        </p:nvSpPr>
+        <p:spPr/>
+        <p:txBody>
+          <a:bodyPr/>
+          <a:lstStyle/>
+          <a:p>
+            <a:pPr lvl="0" indent="0" marL="0">
+              <a:spcBef>
+                <a:spcPts val="3000"/>
+              </a:spcBef>
+              <a:buNone/>
+            </a:pPr>
+            <a:r>
+              <a:rPr b="1"/>
+              <a:t>Convention over configuration</a:t>
+            </a:r>
+          </a:p>
+          <a:p>
+            <a:pPr lvl="0" indent="0" marL="0">
+              <a:buNone/>
+            </a:pPr>
+            <a:r>
+              <a:rPr/>
+              <a:t>The principles are more important that the tools and names.</a:t>
+            </a:r>
+          </a:p>
+          <a:p>
+            <a:pPr lvl="0" indent="0" marL="0">
+              <a:buNone/>
+            </a:pPr>
+            <a:r>
+              <a:rPr/>
+              <a:t>Naming conventions - making purpose obvious:</a:t>
+            </a:r>
+          </a:p>
+          <a:p>
+            <a:pPr lvl="0"/>
+            <a:r>
+              <a:rPr>
+                <a:latin typeface="Courier"/>
+              </a:rPr>
+              <a:t>main</a:t>
+            </a:r>
+            <a:r>
+              <a:rPr/>
+              <a:t> : single source of truth. The only long-living branch.</a:t>
+            </a:r>
+          </a:p>
+          <a:p>
+            <a:pPr lvl="0"/>
+            <a:r>
+              <a:rPr>
+                <a:latin typeface="Courier"/>
+              </a:rPr>
+              <a:t>release/rel-2.0.1</a:t>
+            </a:r>
+            <a:r>
+              <a:rPr/>
+              <a:t> : explicit versioning numbering to identify releases maintenance branch.</a:t>
+            </a:r>
+          </a:p>
+          <a:p>
+            <a:pPr lvl="0"/>
+            <a:r>
+              <a:rPr>
+                <a:latin typeface="Courier"/>
+              </a:rPr>
+              <a:t>epic/47-ai-fraud-detection</a:t>
+            </a:r>
+            <a:r>
+              <a:rPr/>
+              <a:t> : development initiative identified by epic id and description.</a:t>
+            </a:r>
+          </a:p>
+          <a:p>
+            <a:pPr lvl="0"/>
+            <a:r>
+              <a:rPr>
+                <a:latin typeface="Courier"/>
+              </a:rPr>
+              <a:t>feature/&lt;jira-id|servicenow-id&gt;/new-mortgage-calculation</a:t>
+            </a:r>
+            <a:r>
+              <a:rPr/>
+              <a:t> : references to other planning tools for new features for the next planned release.</a:t>
+            </a:r>
+          </a:p>
+          <a:p>
+            <a:pPr lvl="0"/>
+            <a:r>
+              <a:rPr>
+                <a:latin typeface="Courier"/>
+              </a:rPr>
+              <a:t>feature/47-ai-fraud-detection/refactor-mortgage-calculation</a:t>
+            </a:r>
+            <a:r>
+              <a:rPr/>
+              <a:t>: feature implemented for development initiative</a:t>
+            </a:r>
+          </a:p>
+          <a:p>
+            <a:pPr lvl="0"/>
+            <a:r>
+              <a:rPr>
+                <a:latin typeface="Courier"/>
+              </a:rPr>
+              <a:t>hotfix/rel-2.0.1/fix-mortgage-calc</a:t>
+            </a:r>
+            <a:r>
+              <a:rPr/>
+              <a:t>: fix implemented for release rel-2.0.1</a:t>
+            </a:r>
+          </a:p>
+          <a:p>
+            <a:pPr lvl="0" indent="0" marL="0">
+              <a:buNone/>
+            </a:pPr>
+            <a:r>
+              <a:rPr/>
+              <a:t>Names of branches and tags flow through to builds and deployments.</a:t>
+            </a:r>
+          </a:p>
+        </p:txBody>
+      </p:sp>
+    </p:spTree>
+  </p:cSld>
+</p:sld>
+</file>
+
+<file path=ppt/slides/slide13.xml><?xml version="1.0" encoding="utf-8"?>
+<p:sld xmlns:a="http://schemas.openxmlformats.org/drawingml/2006/main" xmlns:r="http://schemas.openxmlformats.org/officeDocument/2006/relationships" xmlns:p="http://schemas.openxmlformats.org/presentationml/2006/main">
+  <p:cSld>
+    <p:spTree>
+      <p:nvGrpSpPr>
+        <p:cNvPr id="1" name=""/>
+        <p:cNvGrpSpPr/>
+        <p:nvPr/>
+      </p:nvGrpSpPr>
+      <p:grpSpPr>
+        <a:xfrm>
+          <a:off x="0" y="0"/>
+          <a:ext cx="0" cy="0"/>
+          <a:chOff x="0" y="0"/>
+          <a:chExt cx="0" cy="0"/>
+        </a:xfrm>
+      </p:grpSpPr>
+      <p:sp>
+        <p:nvSpPr>
           <p:cNvPr id="2" name="Title 1"/>
           <p:cNvSpPr>
             <a:spLocks noGrp="1"/>
@@ -3784,7 +3938,7 @@
             </a:pPr>
             <a:r>
               <a:rPr b="1"/>
-              <a:t>Hot-fix for production</a:t>
+              <a:t>Fix a production defect</a:t>
             </a:r>
           </a:p>
           <a:p>
@@ -4467,107 +4621,6 @@
 </p:sld>
 </file>
 
-<file path=ppt/slides/slide13.xml><?xml version="1.0" encoding="utf-8"?>
-<p:sld xmlns:a="http://schemas.openxmlformats.org/drawingml/2006/main" xmlns:r="http://schemas.openxmlformats.org/officeDocument/2006/relationships" xmlns:p="http://schemas.openxmlformats.org/presentationml/2006/main">
-  <p:cSld>
-    <p:spTree>
-      <p:nvGrpSpPr>
-        <p:cNvPr id="1" name=""/>
-        <p:cNvGrpSpPr/>
-        <p:nvPr/>
-      </p:nvGrpSpPr>
-      <p:grpSpPr>
-        <a:xfrm>
-          <a:off x="0" y="0"/>
-          <a:ext cx="0" cy="0"/>
-          <a:chOff x="0" y="0"/>
-          <a:chExt cx="0" cy="0"/>
-        </a:xfrm>
-      </p:grpSpPr>
-      <p:sp>
-        <p:nvSpPr>
-          <p:cNvPr id="4" name="Text Placeholder 3"/>
-          <p:cNvSpPr>
-            <a:spLocks noGrp="1"/>
-          </p:cNvSpPr>
-          <p:nvPr>
-            <p:ph idx="2" sz="half" type="body"/>
-          </p:nvPr>
-        </p:nvSpPr>
-        <p:spPr/>
-        <p:txBody>
-          <a:bodyPr/>
-          <a:lstStyle/>
-          <a:p>
-            <a:pPr lvl="0" indent="0" marL="0">
-              <a:spcBef>
-                <a:spcPts val="3000"/>
-              </a:spcBef>
-              <a:buNone/>
-            </a:pPr>
-            <a:r>
-              <a:rPr b="1"/>
-              <a:t>Building the fix package</a:t>
-            </a:r>
-          </a:p>
-          <a:p>
-            <a:pPr lvl="0"/>
-            <a:r>
-              <a:rPr/>
-              <a:t>Changes contributed to the release maintenance branch are build and packaged.</a:t>
-            </a:r>
-          </a:p>
-          <a:p>
-            <a:pPr lvl="0"/>
-            <a:r>
-              <a:rPr/>
-              <a:t>The fix package is tested in the appropriate test environment(s)</a:t>
-            </a:r>
-          </a:p>
-          <a:p>
-            <a:pPr lvl="0"/>
-            <a:r>
-              <a:rPr/>
-              <a:t>Finally deployed to production</a:t>
-            </a:r>
-          </a:p>
-        </p:txBody>
-      </p:sp>
-      <p:pic>
-        <p:nvPicPr>
-          <p:cNvPr descr="static/img/branching-model/releaseMaintenanceWorkflow_fixPackageBuild.png" id="0" name="Picture 1"/>
-          <p:cNvPicPr>
-            <a:picLocks noGrp="1" noChangeAspect="1"/>
-          </p:cNvPicPr>
-          <p:nvPr/>
-        </p:nvPicPr>
-        <p:blipFill>
-          <a:blip r:embed="rId2"/>
-          <a:stretch>
-            <a:fillRect/>
-          </a:stretch>
-        </p:blipFill>
-        <p:spPr bwMode="auto">
-          <a:xfrm>
-            <a:off x="3568700" y="355600"/>
-            <a:ext cx="5105400" cy="4064000"/>
-          </a:xfrm>
-          <a:prstGeom prst="rect">
-            <a:avLst/>
-          </a:prstGeom>
-          <a:noFill/>
-          <a:ln w="9525">
-            <a:noFill/>
-            <a:headEnd/>
-            <a:tailEnd/>
-          </a:ln>
-        </p:spPr>
-      </p:pic>
-    </p:spTree>
-  </p:cSld>
-</p:sld>
-</file>
-
 <file path=ppt/slides/slide14.xml><?xml version="1.0" encoding="utf-8"?>
 <p:sld xmlns:a="http://schemas.openxmlformats.org/drawingml/2006/main" xmlns:r="http://schemas.openxmlformats.org/officeDocument/2006/relationships" xmlns:p="http://schemas.openxmlformats.org/presentationml/2006/main">
   <p:cSld>
@@ -4600,23 +4653,6 @@
           <a:bodyPr/>
           <a:lstStyle/>
           <a:p>
-            <a:pPr lvl="0"/>
-            <a:r>
-              <a:rPr/>
-              <a:t>The commit is tagged as the new version </a:t>
-            </a:r>
-            <a:r>
-              <a:rPr>
-                <a:latin typeface="Courier"/>
-              </a:rPr>
-              <a:t>2.1.1</a:t>
-            </a:r>
-            <a:r>
-              <a:rPr/>
-              <a:t>.</a:t>
-            </a:r>
-          </a:p>
-          <a:p>
             <a:pPr lvl="0" indent="0" marL="0">
               <a:spcBef>
                 <a:spcPts val="3000"/>
@@ -4625,6 +4661,186 @@
             </a:pPr>
             <a:r>
               <a:rPr b="1"/>
+              <a:t>Fix a production defect</a:t>
+            </a:r>
+          </a:p>
+          <a:p>
+            <a:pPr lvl="0" indent="0" marL="0">
+              <a:buNone/>
+            </a:pPr>
+            <a:r>
+              <a:rPr b="1"/>
+              <a:t>Developer activities resolving a production defect:</a:t>
+            </a:r>
+          </a:p>
+          <a:p>
+            <a:pPr lvl="0" indent="-342900" marL="342900">
+              <a:buAutoNum type="arabicPeriod"/>
+            </a:pPr>
+            <a:r>
+              <a:rPr/>
+              <a:t>Creates the </a:t>
+            </a:r>
+            <a:r>
+              <a:rPr>
+                <a:latin typeface="Courier"/>
+              </a:rPr>
+              <a:t>release/rel-2.1.0</a:t>
+            </a:r>
+            <a:r>
+              <a:rPr/>
+              <a:t> branch based on the existing Git tag</a:t>
+            </a:r>
+          </a:p>
+          <a:p>
+            <a:pPr lvl="0" indent="-342900" marL="342900">
+              <a:buAutoNum type="arabicPeriod"/>
+            </a:pPr>
+            <a:r>
+              <a:rPr/>
+              <a:t>Creates a feature branch </a:t>
+            </a:r>
+            <a:r>
+              <a:rPr>
+                <a:latin typeface="Courier"/>
+              </a:rPr>
+              <a:t>hotfix/rel-2.1.0/urgent-fix</a:t>
+            </a:r>
+            <a:r>
+              <a:rPr/>
+              <a:t> from the release maintenance branch.</a:t>
+            </a:r>
+          </a:p>
+          <a:p>
+            <a:pPr lvl="0" indent="-342900" marL="342900">
+              <a:buAutoNum type="arabicPeriod"/>
+            </a:pPr>
+            <a:r>
+              <a:rPr/>
+              <a:t>Implement the fix locally</a:t>
+            </a:r>
+          </a:p>
+          <a:p>
+            <a:pPr lvl="0" indent="-342900" marL="342900">
+              <a:buAutoNum type="arabicPeriod"/>
+            </a:pPr>
+            <a:r>
+              <a:rPr/>
+              <a:t>Build with DBB User Build</a:t>
+            </a:r>
+          </a:p>
+          <a:p>
+            <a:pPr lvl="0" indent="-342900" marL="342900">
+              <a:buAutoNum type="arabicPeriod"/>
+            </a:pPr>
+            <a:r>
+              <a:rPr/>
+              <a:t>Commit into hotfix branch, push, build and test feature functionality</a:t>
+            </a:r>
+          </a:p>
+          <a:p>
+            <a:pPr lvl="0" indent="-342900" marL="342900">
+              <a:buAutoNum type="arabicPeriod"/>
+            </a:pPr>
+            <a:r>
+              <a:rPr/>
+              <a:t>Create Pull Request for review and approval</a:t>
+            </a:r>
+          </a:p>
+          <a:p>
+            <a:pPr lvl="0" indent="0" marL="0">
+              <a:spcBef>
+                <a:spcPts val="3000"/>
+              </a:spcBef>
+              <a:buNone/>
+            </a:pPr>
+            <a:r>
+              <a:rPr b="1"/>
+              <a:t>Fix a production defect</a:t>
+            </a:r>
+          </a:p>
+          <a:p>
+            <a:pPr lvl="0" indent="0" marL="0">
+              <a:buNone/>
+            </a:pPr>
+            <a:r>
+              <a:rPr b="1"/>
+              <a:t>Release control activities resolving a production defect:</a:t>
+            </a:r>
+          </a:p>
+          <a:p>
+            <a:pPr lvl="0" indent="-342900" marL="342900">
+              <a:buAutoNum startAt="7" type="arabicPeriod"/>
+            </a:pPr>
+            <a:r>
+              <a:rPr/>
+              <a:t>Merge hotfix branch to release maintenance branch and build</a:t>
+            </a:r>
+          </a:p>
+          <a:p>
+            <a:pPr lvl="0" indent="-342900" marL="342900">
+              <a:buAutoNum startAt="7" type="arabicPeriod"/>
+            </a:pPr>
+            <a:r>
+              <a:rPr/>
+              <a:t>Use release pipeline to create fix package</a:t>
+            </a:r>
+          </a:p>
+          <a:p>
+            <a:pPr lvl="0" indent="-342900" marL="342900">
+              <a:buAutoNum startAt="7" type="arabicPeriod"/>
+            </a:pPr>
+            <a:r>
+              <a:rPr/>
+              <a:t>Deploy fix package to controlled test environments and test it</a:t>
+            </a:r>
+          </a:p>
+          <a:p>
+            <a:pPr lvl="0" indent="-342900" marL="342900">
+              <a:buAutoNum startAt="7" type="arabicPeriod"/>
+            </a:pPr>
+            <a:r>
+              <a:rPr/>
+              <a:t>Deploy fix package to production</a:t>
+            </a:r>
+          </a:p>
+          <a:p>
+            <a:pPr lvl="0" indent="-342900" marL="342900">
+              <a:buAutoNum startAt="7" type="arabicPeriod"/>
+            </a:pPr>
+            <a:r>
+              <a:rPr/>
+              <a:t>Tag commit from step 8 indicating the new version</a:t>
+            </a:r>
+          </a:p>
+          <a:p>
+            <a:pPr lvl="0" indent="-342900" marL="342900">
+              <a:buAutoNum startAt="7" type="arabicPeriod"/>
+            </a:pPr>
+            <a:r>
+              <a:rPr/>
+              <a:t>Merge release maintenance branch into </a:t>
+            </a:r>
+            <a:r>
+              <a:rPr>
+                <a:latin typeface="Courier"/>
+              </a:rPr>
+              <a:t>main</a:t>
+            </a:r>
+            <a:r>
+              <a:rPr/>
+              <a:t>.</a:t>
+            </a:r>
+          </a:p>
+          <a:p>
+            <a:pPr lvl="0" indent="0" marL="0">
+              <a:spcBef>
+                <a:spcPts val="3000"/>
+              </a:spcBef>
+              <a:buNone/>
+            </a:pPr>
+            <a:r>
+              <a:rPr b="1"/>
               <a:t>Using the Epic branch workflow</a:t>
             </a:r>
           </a:p>
@@ -4665,7 +4881,225 @@
             </a:pPr>
             <a:r>
               <a:rPr/>
-              <a:t>→ A process to work independently from the default workflow.</a:t>
+              <a:t>→ A process to work independently from the base workflow.</a:t>
+            </a:r>
+          </a:p>
+          <a:p>
+            <a:pPr lvl="0" indent="0" marL="0">
+              <a:spcBef>
+                <a:spcPts val="3000"/>
+              </a:spcBef>
+              <a:buNone/>
+            </a:pPr>
+            <a:r>
+              <a:rPr b="1"/>
+              <a:t>Using the Epic branch workflow</a:t>
+            </a:r>
+          </a:p>
+          <a:p>
+            <a:pPr lvl="0" indent="0" marL="0">
+              <a:buNone/>
+            </a:pPr>
+            <a:r>
+              <a:rPr b="1"/>
+              <a:t>Developer activities for implementing significant development initiatives:</a:t>
+            </a:r>
+          </a:p>
+          <a:p>
+            <a:pPr lvl="0" indent="-342900" marL="342900">
+              <a:buAutoNum type="arabicPeriod"/>
+            </a:pPr>
+            <a:r>
+              <a:rPr/>
+              <a:t>Creates the </a:t>
+            </a:r>
+            <a:r>
+              <a:rPr>
+                <a:latin typeface="Courier"/>
+              </a:rPr>
+              <a:t>epic/ai-fraud-detection</a:t>
+            </a:r>
+            <a:r>
+              <a:rPr/>
+              <a:t> branch based on the existing Git tag</a:t>
+            </a:r>
+          </a:p>
+          <a:p>
+            <a:pPr lvl="0" indent="-342900" marL="342900">
+              <a:buAutoNum type="arabicPeriod"/>
+            </a:pPr>
+            <a:r>
+              <a:rPr/>
+              <a:t>Creates a feature branch </a:t>
+            </a:r>
+            <a:r>
+              <a:rPr>
+                <a:latin typeface="Courier"/>
+              </a:rPr>
+              <a:t>feature/ai-fraud-detection/introduce-ai-model-to-mortgage-calculation</a:t>
+            </a:r>
+            <a:r>
+              <a:rPr/>
+              <a:t> from the epic branch.</a:t>
+            </a:r>
+          </a:p>
+          <a:p>
+            <a:pPr lvl="0" indent="-342900" marL="342900">
+              <a:buAutoNum type="arabicPeriod"/>
+            </a:pPr>
+            <a:r>
+              <a:rPr/>
+              <a:t>Code locally</a:t>
+            </a:r>
+          </a:p>
+          <a:p>
+            <a:pPr lvl="0" indent="-342900" marL="342900">
+              <a:buAutoNum type="arabicPeriod"/>
+            </a:pPr>
+            <a:r>
+              <a:rPr/>
+              <a:t>Build with DBB User Build</a:t>
+            </a:r>
+          </a:p>
+          <a:p>
+            <a:pPr lvl="0" indent="-342900" marL="342900">
+              <a:buAutoNum type="arabicPeriod"/>
+            </a:pPr>
+            <a:r>
+              <a:rPr/>
+              <a:t>Commit into feature branch, push, build and test feature functionality</a:t>
+            </a:r>
+          </a:p>
+          <a:p>
+            <a:pPr lvl="0" indent="-342900" marL="342900">
+              <a:buAutoNum type="arabicPeriod"/>
+            </a:pPr>
+            <a:r>
+              <a:rPr/>
+              <a:t>Create Pull Request for review and approval to merge into the integration branch</a:t>
+            </a:r>
+          </a:p>
+          <a:p>
+            <a:pPr lvl="0" indent="0" marL="0">
+              <a:spcBef>
+                <a:spcPts val="3000"/>
+              </a:spcBef>
+              <a:buNone/>
+            </a:pPr>
+            <a:r>
+              <a:rPr b="1"/>
+              <a:t>Using the Epic branch workflow</a:t>
+            </a:r>
+          </a:p>
+          <a:p>
+            <a:pPr lvl="0" indent="0" marL="0">
+              <a:buNone/>
+            </a:pPr>
+            <a:r>
+              <a:rPr b="1"/>
+              <a:t>Release activities for implementing significant development initiatives:</a:t>
+            </a:r>
+          </a:p>
+          <a:p>
+            <a:pPr lvl="0" indent="-342900" marL="342900">
+              <a:buAutoNum startAt="7" type="arabicPeriod"/>
+            </a:pPr>
+            <a:r>
+              <a:rPr/>
+              <a:t>Merge feature branch to epic branch and build</a:t>
+            </a:r>
+          </a:p>
+          <a:p>
+            <a:pPr lvl="0" indent="-342900" marL="342900">
+              <a:buAutoNum startAt="7" type="arabicPeriod"/>
+            </a:pPr>
+            <a:r>
+              <a:rPr/>
+              <a:t>Use release pipeline to create preliminary package</a:t>
+            </a:r>
+          </a:p>
+          <a:p>
+            <a:pPr lvl="0" indent="-342900" marL="342900">
+              <a:buAutoNum startAt="7" type="arabicPeriod"/>
+            </a:pPr>
+            <a:r>
+              <a:rPr/>
+              <a:t>Deploy package to project test environment</a:t>
+            </a:r>
+          </a:p>
+          <a:p>
+            <a:pPr lvl="0" indent="-342900" marL="342900">
+              <a:buAutoNum startAt="7" type="arabicPeriod"/>
+            </a:pPr>
+            <a:r>
+              <a:rPr/>
+              <a:t>Frequently synchronize with </a:t>
+            </a:r>
+            <a:r>
+              <a:rPr>
+                <a:latin typeface="Courier"/>
+              </a:rPr>
+              <a:t>main</a:t>
+            </a:r>
+            <a:r>
+              <a:rPr/>
+              <a:t> into the epic branch to avoid making the merge of the </a:t>
+            </a:r>
+            <a:r>
+              <a:rPr>
+                <a:latin typeface="Courier"/>
+              </a:rPr>
+              <a:t>epic</a:t>
+            </a:r>
+            <a:r>
+              <a:rPr/>
+              <a:t> branch into </a:t>
+            </a:r>
+            <a:r>
+              <a:rPr>
+                <a:latin typeface="Courier"/>
+              </a:rPr>
+              <a:t>main</a:t>
+            </a:r>
+            <a:r>
+              <a:rPr/>
+              <a:t> difficult.</a:t>
+            </a:r>
+          </a:p>
+          <a:p>
+            <a:pPr lvl="0" indent="-342900" marL="342900">
+              <a:buAutoNum startAt="7" type="arabicPeriod"/>
+            </a:pPr>
+            <a:r>
+              <a:rPr/>
+              <a:t>Decision </a:t>
+            </a:r>
+            <a:r>
+              <a:rPr b="1"/>
+              <a:t>when</a:t>
+            </a:r>
+            <a:r>
+              <a:rPr/>
+              <a:t> the changes on the epic branch should be released</a:t>
+            </a:r>
+          </a:p>
+          <a:p>
+            <a:pPr lvl="0" indent="-342900" marL="342900">
+              <a:buAutoNum startAt="7" type="arabicPeriod"/>
+            </a:pPr>
+            <a:r>
+              <a:rPr/>
+              <a:t>Merge epic branch into </a:t>
+            </a:r>
+            <a:r>
+              <a:rPr>
+                <a:latin typeface="Courier"/>
+              </a:rPr>
+              <a:t>main</a:t>
+            </a:r>
+            <a:r>
+              <a:rPr/>
+              <a:t> and deliver via the base workflow.</a:t>
             </a:r>
           </a:p>
           <a:p>
@@ -4714,104 +5148,1219 @@
       </p:pic>
     </p:spTree>
   </p:cSld>
+  <p:timing>
+    <p:tnLst>
+      <p:par>
+        <p:cTn id="1" dur="indefinite" restart="never" nodeType="tmRoot">
+          <p:childTnLst>
+            <p:seq concurrent="1" nextAc="seek">
+              <p:cTn id="2" dur="indefinite" nodeType="mainSeq">
+                <p:childTnLst>
+                  <p:par>
+                    <p:cTn id="3" fill="hold">
+                      <p:stCondLst>
+                        <p:cond delay="indefinite"/>
+                      </p:stCondLst>
+                      <p:childTnLst>
+                        <p:par>
+                          <p:cTn id="4" fill="hold">
+                            <p:stCondLst>
+                              <p:cond delay="0"/>
+                            </p:stCondLst>
+                            <p:childTnLst>
+                              <p:par>
+                                <p:cTn id="5" presetID="1" presetClass="entr" presetSubtype="0" fill="hold" grpId="0" nodeType="clickEffect">
+                                  <p:stCondLst>
+                                    <p:cond delay="0"/>
+                                  </p:stCondLst>
+                                  <p:childTnLst>
+                                    <p:set>
+                                      <p:cBhvr>
+                                        <p:cTn id="6" dur="1" fill="hold">
+                                          <p:stCondLst>
+                                            <p:cond delay="0"/>
+                                          </p:stCondLst>
+                                        </p:cTn>
+                                        <p:tgtEl>
+                                          <p:spTgt spid="4">
+                                            <p:txEl>
+                                              <p:pRg st="2" end="2"/>
+                                            </p:txEl>
+                                          </p:spTgt>
+                                        </p:tgtEl>
+                                        <p:attrNameLst>
+                                          <p:attrName>style.visibility</p:attrName>
+                                        </p:attrNameLst>
+                                      </p:cBhvr>
+                                      <p:to>
+                                        <p:strVal val="visible"/>
+                                      </p:to>
+                                    </p:set>
+                                  </p:childTnLst>
+                                </p:cTn>
+                              </p:par>
+                            </p:childTnLst>
+                          </p:cTn>
+                        </p:par>
+                      </p:childTnLst>
+                    </p:cTn>
+                  </p:par>
+                  <p:par>
+                    <p:cTn id="7" fill="hold">
+                      <p:stCondLst>
+                        <p:cond delay="indefinite"/>
+                      </p:stCondLst>
+                      <p:childTnLst>
+                        <p:par>
+                          <p:cTn id="8" fill="hold">
+                            <p:stCondLst>
+                              <p:cond delay="0"/>
+                            </p:stCondLst>
+                            <p:childTnLst>
+                              <p:par>
+                                <p:cTn id="9" presetID="1" presetClass="entr" presetSubtype="0" fill="hold" grpId="0" nodeType="clickEffect">
+                                  <p:stCondLst>
+                                    <p:cond delay="0"/>
+                                  </p:stCondLst>
+                                  <p:childTnLst>
+                                    <p:set>
+                                      <p:cBhvr>
+                                        <p:cTn id="10" dur="1" fill="hold">
+                                          <p:stCondLst>
+                                            <p:cond delay="0"/>
+                                          </p:stCondLst>
+                                        </p:cTn>
+                                        <p:tgtEl>
+                                          <p:spTgt spid="4">
+                                            <p:txEl>
+                                              <p:pRg st="3" end="3"/>
+                                            </p:txEl>
+                                          </p:spTgt>
+                                        </p:tgtEl>
+                                        <p:attrNameLst>
+                                          <p:attrName>style.visibility</p:attrName>
+                                        </p:attrNameLst>
+                                      </p:cBhvr>
+                                      <p:to>
+                                        <p:strVal val="visible"/>
+                                      </p:to>
+                                    </p:set>
+                                  </p:childTnLst>
+                                </p:cTn>
+                              </p:par>
+                            </p:childTnLst>
+                          </p:cTn>
+                        </p:par>
+                      </p:childTnLst>
+                    </p:cTn>
+                  </p:par>
+                  <p:par>
+                    <p:cTn id="11" fill="hold">
+                      <p:stCondLst>
+                        <p:cond delay="indefinite"/>
+                      </p:stCondLst>
+                      <p:childTnLst>
+                        <p:par>
+                          <p:cTn id="12" fill="hold">
+                            <p:stCondLst>
+                              <p:cond delay="0"/>
+                            </p:stCondLst>
+                            <p:childTnLst>
+                              <p:par>
+                                <p:cTn id="13" presetID="1" presetClass="entr" presetSubtype="0" fill="hold" grpId="0" nodeType="clickEffect">
+                                  <p:stCondLst>
+                                    <p:cond delay="0"/>
+                                  </p:stCondLst>
+                                  <p:childTnLst>
+                                    <p:set>
+                                      <p:cBhvr>
+                                        <p:cTn id="14" dur="1" fill="hold">
+                                          <p:stCondLst>
+                                            <p:cond delay="0"/>
+                                          </p:stCondLst>
+                                        </p:cTn>
+                                        <p:tgtEl>
+                                          <p:spTgt spid="4">
+                                            <p:txEl>
+                                              <p:pRg st="4" end="4"/>
+                                            </p:txEl>
+                                          </p:spTgt>
+                                        </p:tgtEl>
+                                        <p:attrNameLst>
+                                          <p:attrName>style.visibility</p:attrName>
+                                        </p:attrNameLst>
+                                      </p:cBhvr>
+                                      <p:to>
+                                        <p:strVal val="visible"/>
+                                      </p:to>
+                                    </p:set>
+                                  </p:childTnLst>
+                                </p:cTn>
+                              </p:par>
+                            </p:childTnLst>
+                          </p:cTn>
+                        </p:par>
+                      </p:childTnLst>
+                    </p:cTn>
+                  </p:par>
+                  <p:par>
+                    <p:cTn id="15" fill="hold">
+                      <p:stCondLst>
+                        <p:cond delay="indefinite"/>
+                      </p:stCondLst>
+                      <p:childTnLst>
+                        <p:par>
+                          <p:cTn id="16" fill="hold">
+                            <p:stCondLst>
+                              <p:cond delay="0"/>
+                            </p:stCondLst>
+                            <p:childTnLst>
+                              <p:par>
+                                <p:cTn id="17" presetID="1" presetClass="entr" presetSubtype="0" fill="hold" grpId="0" nodeType="clickEffect">
+                                  <p:stCondLst>
+                                    <p:cond delay="0"/>
+                                  </p:stCondLst>
+                                  <p:childTnLst>
+                                    <p:set>
+                                      <p:cBhvr>
+                                        <p:cTn id="18" dur="1" fill="hold">
+                                          <p:stCondLst>
+                                            <p:cond delay="0"/>
+                                          </p:stCondLst>
+                                        </p:cTn>
+                                        <p:tgtEl>
+                                          <p:spTgt spid="4">
+                                            <p:txEl>
+                                              <p:pRg st="5" end="5"/>
+                                            </p:txEl>
+                                          </p:spTgt>
+                                        </p:tgtEl>
+                                        <p:attrNameLst>
+                                          <p:attrName>style.visibility</p:attrName>
+                                        </p:attrNameLst>
+                                      </p:cBhvr>
+                                      <p:to>
+                                        <p:strVal val="visible"/>
+                                      </p:to>
+                                    </p:set>
+                                  </p:childTnLst>
+                                </p:cTn>
+                              </p:par>
+                            </p:childTnLst>
+                          </p:cTn>
+                        </p:par>
+                      </p:childTnLst>
+                    </p:cTn>
+                  </p:par>
+                  <p:par>
+                    <p:cTn id="19" fill="hold">
+                      <p:stCondLst>
+                        <p:cond delay="indefinite"/>
+                      </p:stCondLst>
+                      <p:childTnLst>
+                        <p:par>
+                          <p:cTn id="20" fill="hold">
+                            <p:stCondLst>
+                              <p:cond delay="0"/>
+                            </p:stCondLst>
+                            <p:childTnLst>
+                              <p:par>
+                                <p:cTn id="21" presetID="1" presetClass="entr" presetSubtype="0" fill="hold" grpId="0" nodeType="clickEffect">
+                                  <p:stCondLst>
+                                    <p:cond delay="0"/>
+                                  </p:stCondLst>
+                                  <p:childTnLst>
+                                    <p:set>
+                                      <p:cBhvr>
+                                        <p:cTn id="22" dur="1" fill="hold">
+                                          <p:stCondLst>
+                                            <p:cond delay="0"/>
+                                          </p:stCondLst>
+                                        </p:cTn>
+                                        <p:tgtEl>
+                                          <p:spTgt spid="4">
+                                            <p:txEl>
+                                              <p:pRg st="6" end="6"/>
+                                            </p:txEl>
+                                          </p:spTgt>
+                                        </p:tgtEl>
+                                        <p:attrNameLst>
+                                          <p:attrName>style.visibility</p:attrName>
+                                        </p:attrNameLst>
+                                      </p:cBhvr>
+                                      <p:to>
+                                        <p:strVal val="visible"/>
+                                      </p:to>
+                                    </p:set>
+                                  </p:childTnLst>
+                                </p:cTn>
+                              </p:par>
+                            </p:childTnLst>
+                          </p:cTn>
+                        </p:par>
+                      </p:childTnLst>
+                    </p:cTn>
+                  </p:par>
+                  <p:par>
+                    <p:cTn id="23" fill="hold">
+                      <p:stCondLst>
+                        <p:cond delay="indefinite"/>
+                      </p:stCondLst>
+                      <p:childTnLst>
+                        <p:par>
+                          <p:cTn id="24" fill="hold">
+                            <p:stCondLst>
+                              <p:cond delay="0"/>
+                            </p:stCondLst>
+                            <p:childTnLst>
+                              <p:par>
+                                <p:cTn id="25" presetID="1" presetClass="entr" presetSubtype="0" fill="hold" grpId="0" nodeType="clickEffect">
+                                  <p:stCondLst>
+                                    <p:cond delay="0"/>
+                                  </p:stCondLst>
+                                  <p:childTnLst>
+                                    <p:set>
+                                      <p:cBhvr>
+                                        <p:cTn id="26" dur="1" fill="hold">
+                                          <p:stCondLst>
+                                            <p:cond delay="0"/>
+                                          </p:stCondLst>
+                                        </p:cTn>
+                                        <p:tgtEl>
+                                          <p:spTgt spid="4">
+                                            <p:txEl>
+                                              <p:pRg st="7" end="7"/>
+                                            </p:txEl>
+                                          </p:spTgt>
+                                        </p:tgtEl>
+                                        <p:attrNameLst>
+                                          <p:attrName>style.visibility</p:attrName>
+                                        </p:attrNameLst>
+                                      </p:cBhvr>
+                                      <p:to>
+                                        <p:strVal val="visible"/>
+                                      </p:to>
+                                    </p:set>
+                                  </p:childTnLst>
+                                </p:cTn>
+                              </p:par>
+                            </p:childTnLst>
+                          </p:cTn>
+                        </p:par>
+                      </p:childTnLst>
+                    </p:cTn>
+                  </p:par>
+                  <p:par>
+                    <p:cTn id="27" fill="hold">
+                      <p:stCondLst>
+                        <p:cond delay="indefinite"/>
+                      </p:stCondLst>
+                      <p:childTnLst>
+                        <p:par>
+                          <p:cTn id="28" fill="hold">
+                            <p:stCondLst>
+                              <p:cond delay="0"/>
+                            </p:stCondLst>
+                            <p:childTnLst>
+                              <p:par>
+                                <p:cTn id="29" presetID="1" presetClass="entr" presetSubtype="0" fill="hold" grpId="0" nodeType="clickEffect">
+                                  <p:stCondLst>
+                                    <p:cond delay="0"/>
+                                  </p:stCondLst>
+                                  <p:childTnLst>
+                                    <p:set>
+                                      <p:cBhvr>
+                                        <p:cTn id="30" dur="1" fill="hold">
+                                          <p:stCondLst>
+                                            <p:cond delay="0"/>
+                                          </p:stCondLst>
+                                        </p:cTn>
+                                        <p:tgtEl>
+                                          <p:spTgt spid="4">
+                                            <p:txEl>
+                                              <p:pRg st="10" end="10"/>
+                                            </p:txEl>
+                                          </p:spTgt>
+                                        </p:tgtEl>
+                                        <p:attrNameLst>
+                                          <p:attrName>style.visibility</p:attrName>
+                                        </p:attrNameLst>
+                                      </p:cBhvr>
+                                      <p:to>
+                                        <p:strVal val="visible"/>
+                                      </p:to>
+                                    </p:set>
+                                  </p:childTnLst>
+                                </p:cTn>
+                              </p:par>
+                            </p:childTnLst>
+                          </p:cTn>
+                        </p:par>
+                      </p:childTnLst>
+                    </p:cTn>
+                  </p:par>
+                  <p:par>
+                    <p:cTn id="31" fill="hold">
+                      <p:stCondLst>
+                        <p:cond delay="indefinite"/>
+                      </p:stCondLst>
+                      <p:childTnLst>
+                        <p:par>
+                          <p:cTn id="32" fill="hold">
+                            <p:stCondLst>
+                              <p:cond delay="0"/>
+                            </p:stCondLst>
+                            <p:childTnLst>
+                              <p:par>
+                                <p:cTn id="33" presetID="1" presetClass="entr" presetSubtype="0" fill="hold" grpId="0" nodeType="clickEffect">
+                                  <p:stCondLst>
+                                    <p:cond delay="0"/>
+                                  </p:stCondLst>
+                                  <p:childTnLst>
+                                    <p:set>
+                                      <p:cBhvr>
+                                        <p:cTn id="34" dur="1" fill="hold">
+                                          <p:stCondLst>
+                                            <p:cond delay="0"/>
+                                          </p:stCondLst>
+                                        </p:cTn>
+                                        <p:tgtEl>
+                                          <p:spTgt spid="4">
+                                            <p:txEl>
+                                              <p:pRg st="11" end="11"/>
+                                            </p:txEl>
+                                          </p:spTgt>
+                                        </p:tgtEl>
+                                        <p:attrNameLst>
+                                          <p:attrName>style.visibility</p:attrName>
+                                        </p:attrNameLst>
+                                      </p:cBhvr>
+                                      <p:to>
+                                        <p:strVal val="visible"/>
+                                      </p:to>
+                                    </p:set>
+                                  </p:childTnLst>
+                                </p:cTn>
+                              </p:par>
+                            </p:childTnLst>
+                          </p:cTn>
+                        </p:par>
+                      </p:childTnLst>
+                    </p:cTn>
+                  </p:par>
+                  <p:par>
+                    <p:cTn id="35" fill="hold">
+                      <p:stCondLst>
+                        <p:cond delay="indefinite"/>
+                      </p:stCondLst>
+                      <p:childTnLst>
+                        <p:par>
+                          <p:cTn id="36" fill="hold">
+                            <p:stCondLst>
+                              <p:cond delay="0"/>
+                            </p:stCondLst>
+                            <p:childTnLst>
+                              <p:par>
+                                <p:cTn id="37" presetID="1" presetClass="entr" presetSubtype="0" fill="hold" grpId="0" nodeType="clickEffect">
+                                  <p:stCondLst>
+                                    <p:cond delay="0"/>
+                                  </p:stCondLst>
+                                  <p:childTnLst>
+                                    <p:set>
+                                      <p:cBhvr>
+                                        <p:cTn id="38" dur="1" fill="hold">
+                                          <p:stCondLst>
+                                            <p:cond delay="0"/>
+                                          </p:stCondLst>
+                                        </p:cTn>
+                                        <p:tgtEl>
+                                          <p:spTgt spid="4">
+                                            <p:txEl>
+                                              <p:pRg st="12" end="12"/>
+                                            </p:txEl>
+                                          </p:spTgt>
+                                        </p:tgtEl>
+                                        <p:attrNameLst>
+                                          <p:attrName>style.visibility</p:attrName>
+                                        </p:attrNameLst>
+                                      </p:cBhvr>
+                                      <p:to>
+                                        <p:strVal val="visible"/>
+                                      </p:to>
+                                    </p:set>
+                                  </p:childTnLst>
+                                </p:cTn>
+                              </p:par>
+                            </p:childTnLst>
+                          </p:cTn>
+                        </p:par>
+                      </p:childTnLst>
+                    </p:cTn>
+                  </p:par>
+                  <p:par>
+                    <p:cTn id="39" fill="hold">
+                      <p:stCondLst>
+                        <p:cond delay="indefinite"/>
+                      </p:stCondLst>
+                      <p:childTnLst>
+                        <p:par>
+                          <p:cTn id="40" fill="hold">
+                            <p:stCondLst>
+                              <p:cond delay="0"/>
+                            </p:stCondLst>
+                            <p:childTnLst>
+                              <p:par>
+                                <p:cTn id="41" presetID="1" presetClass="entr" presetSubtype="0" fill="hold" grpId="0" nodeType="clickEffect">
+                                  <p:stCondLst>
+                                    <p:cond delay="0"/>
+                                  </p:stCondLst>
+                                  <p:childTnLst>
+                                    <p:set>
+                                      <p:cBhvr>
+                                        <p:cTn id="42" dur="1" fill="hold">
+                                          <p:stCondLst>
+                                            <p:cond delay="0"/>
+                                          </p:stCondLst>
+                                        </p:cTn>
+                                        <p:tgtEl>
+                                          <p:spTgt spid="4">
+                                            <p:txEl>
+                                              <p:pRg st="13" end="13"/>
+                                            </p:txEl>
+                                          </p:spTgt>
+                                        </p:tgtEl>
+                                        <p:attrNameLst>
+                                          <p:attrName>style.visibility</p:attrName>
+                                        </p:attrNameLst>
+                                      </p:cBhvr>
+                                      <p:to>
+                                        <p:strVal val="visible"/>
+                                      </p:to>
+                                    </p:set>
+                                  </p:childTnLst>
+                                </p:cTn>
+                              </p:par>
+                            </p:childTnLst>
+                          </p:cTn>
+                        </p:par>
+                      </p:childTnLst>
+                    </p:cTn>
+                  </p:par>
+                  <p:par>
+                    <p:cTn id="43" fill="hold">
+                      <p:stCondLst>
+                        <p:cond delay="indefinite"/>
+                      </p:stCondLst>
+                      <p:childTnLst>
+                        <p:par>
+                          <p:cTn id="44" fill="hold">
+                            <p:stCondLst>
+                              <p:cond delay="0"/>
+                            </p:stCondLst>
+                            <p:childTnLst>
+                              <p:par>
+                                <p:cTn id="45" presetID="1" presetClass="entr" presetSubtype="0" fill="hold" grpId="0" nodeType="clickEffect">
+                                  <p:stCondLst>
+                                    <p:cond delay="0"/>
+                                  </p:stCondLst>
+                                  <p:childTnLst>
+                                    <p:set>
+                                      <p:cBhvr>
+                                        <p:cTn id="46" dur="1" fill="hold">
+                                          <p:stCondLst>
+                                            <p:cond delay="0"/>
+                                          </p:stCondLst>
+                                        </p:cTn>
+                                        <p:tgtEl>
+                                          <p:spTgt spid="4">
+                                            <p:txEl>
+                                              <p:pRg st="14" end="14"/>
+                                            </p:txEl>
+                                          </p:spTgt>
+                                        </p:tgtEl>
+                                        <p:attrNameLst>
+                                          <p:attrName>style.visibility</p:attrName>
+                                        </p:attrNameLst>
+                                      </p:cBhvr>
+                                      <p:to>
+                                        <p:strVal val="visible"/>
+                                      </p:to>
+                                    </p:set>
+                                  </p:childTnLst>
+                                </p:cTn>
+                              </p:par>
+                            </p:childTnLst>
+                          </p:cTn>
+                        </p:par>
+                      </p:childTnLst>
+                    </p:cTn>
+                  </p:par>
+                  <p:par>
+                    <p:cTn id="47" fill="hold">
+                      <p:stCondLst>
+                        <p:cond delay="indefinite"/>
+                      </p:stCondLst>
+                      <p:childTnLst>
+                        <p:par>
+                          <p:cTn id="48" fill="hold">
+                            <p:stCondLst>
+                              <p:cond delay="0"/>
+                            </p:stCondLst>
+                            <p:childTnLst>
+                              <p:par>
+                                <p:cTn id="49" presetID="1" presetClass="entr" presetSubtype="0" fill="hold" grpId="0" nodeType="clickEffect">
+                                  <p:stCondLst>
+                                    <p:cond delay="0"/>
+                                  </p:stCondLst>
+                                  <p:childTnLst>
+                                    <p:set>
+                                      <p:cBhvr>
+                                        <p:cTn id="50" dur="1" fill="hold">
+                                          <p:stCondLst>
+                                            <p:cond delay="0"/>
+                                          </p:stCondLst>
+                                        </p:cTn>
+                                        <p:tgtEl>
+                                          <p:spTgt spid="4">
+                                            <p:txEl>
+                                              <p:pRg st="15" end="15"/>
+                                            </p:txEl>
+                                          </p:spTgt>
+                                        </p:tgtEl>
+                                        <p:attrNameLst>
+                                          <p:attrName>style.visibility</p:attrName>
+                                        </p:attrNameLst>
+                                      </p:cBhvr>
+                                      <p:to>
+                                        <p:strVal val="visible"/>
+                                      </p:to>
+                                    </p:set>
+                                  </p:childTnLst>
+                                </p:cTn>
+                              </p:par>
+                            </p:childTnLst>
+                          </p:cTn>
+                        </p:par>
+                      </p:childTnLst>
+                    </p:cTn>
+                  </p:par>
+                  <p:par>
+                    <p:cTn id="51" fill="hold">
+                      <p:stCondLst>
+                        <p:cond delay="indefinite"/>
+                      </p:stCondLst>
+                      <p:childTnLst>
+                        <p:par>
+                          <p:cTn id="52" fill="hold">
+                            <p:stCondLst>
+                              <p:cond delay="0"/>
+                            </p:stCondLst>
+                            <p:childTnLst>
+                              <p:par>
+                                <p:cTn id="53" presetID="1" presetClass="entr" presetSubtype="0" fill="hold" grpId="0" nodeType="clickEffect">
+                                  <p:stCondLst>
+                                    <p:cond delay="0"/>
+                                  </p:stCondLst>
+                                  <p:childTnLst>
+                                    <p:set>
+                                      <p:cBhvr>
+                                        <p:cTn id="54" dur="1" fill="hold">
+                                          <p:stCondLst>
+                                            <p:cond delay="0"/>
+                                          </p:stCondLst>
+                                        </p:cTn>
+                                        <p:tgtEl>
+                                          <p:spTgt spid="4">
+                                            <p:txEl>
+                                              <p:pRg st="23" end="23"/>
+                                            </p:txEl>
+                                          </p:spTgt>
+                                        </p:tgtEl>
+                                        <p:attrNameLst>
+                                          <p:attrName>style.visibility</p:attrName>
+                                        </p:attrNameLst>
+                                      </p:cBhvr>
+                                      <p:to>
+                                        <p:strVal val="visible"/>
+                                      </p:to>
+                                    </p:set>
+                                  </p:childTnLst>
+                                </p:cTn>
+                              </p:par>
+                            </p:childTnLst>
+                          </p:cTn>
+                        </p:par>
+                      </p:childTnLst>
+                    </p:cTn>
+                  </p:par>
+                  <p:par>
+                    <p:cTn id="55" fill="hold">
+                      <p:stCondLst>
+                        <p:cond delay="indefinite"/>
+                      </p:stCondLst>
+                      <p:childTnLst>
+                        <p:par>
+                          <p:cTn id="56" fill="hold">
+                            <p:stCondLst>
+                              <p:cond delay="0"/>
+                            </p:stCondLst>
+                            <p:childTnLst>
+                              <p:par>
+                                <p:cTn id="57" presetID="1" presetClass="entr" presetSubtype="0" fill="hold" grpId="0" nodeType="clickEffect">
+                                  <p:stCondLst>
+                                    <p:cond delay="0"/>
+                                  </p:stCondLst>
+                                  <p:childTnLst>
+                                    <p:set>
+                                      <p:cBhvr>
+                                        <p:cTn id="58" dur="1" fill="hold">
+                                          <p:stCondLst>
+                                            <p:cond delay="0"/>
+                                          </p:stCondLst>
+                                        </p:cTn>
+                                        <p:tgtEl>
+                                          <p:spTgt spid="4">
+                                            <p:txEl>
+                                              <p:pRg st="24" end="24"/>
+                                            </p:txEl>
+                                          </p:spTgt>
+                                        </p:tgtEl>
+                                        <p:attrNameLst>
+                                          <p:attrName>style.visibility</p:attrName>
+                                        </p:attrNameLst>
+                                      </p:cBhvr>
+                                      <p:to>
+                                        <p:strVal val="visible"/>
+                                      </p:to>
+                                    </p:set>
+                                  </p:childTnLst>
+                                </p:cTn>
+                              </p:par>
+                            </p:childTnLst>
+                          </p:cTn>
+                        </p:par>
+                      </p:childTnLst>
+                    </p:cTn>
+                  </p:par>
+                  <p:par>
+                    <p:cTn id="59" fill="hold">
+                      <p:stCondLst>
+                        <p:cond delay="indefinite"/>
+                      </p:stCondLst>
+                      <p:childTnLst>
+                        <p:par>
+                          <p:cTn id="60" fill="hold">
+                            <p:stCondLst>
+                              <p:cond delay="0"/>
+                            </p:stCondLst>
+                            <p:childTnLst>
+                              <p:par>
+                                <p:cTn id="61" presetID="1" presetClass="entr" presetSubtype="0" fill="hold" grpId="0" nodeType="clickEffect">
+                                  <p:stCondLst>
+                                    <p:cond delay="0"/>
+                                  </p:stCondLst>
+                                  <p:childTnLst>
+                                    <p:set>
+                                      <p:cBhvr>
+                                        <p:cTn id="62" dur="1" fill="hold">
+                                          <p:stCondLst>
+                                            <p:cond delay="0"/>
+                                          </p:stCondLst>
+                                        </p:cTn>
+                                        <p:tgtEl>
+                                          <p:spTgt spid="4">
+                                            <p:txEl>
+                                              <p:pRg st="25" end="25"/>
+                                            </p:txEl>
+                                          </p:spTgt>
+                                        </p:tgtEl>
+                                        <p:attrNameLst>
+                                          <p:attrName>style.visibility</p:attrName>
+                                        </p:attrNameLst>
+                                      </p:cBhvr>
+                                      <p:to>
+                                        <p:strVal val="visible"/>
+                                      </p:to>
+                                    </p:set>
+                                  </p:childTnLst>
+                                </p:cTn>
+                              </p:par>
+                            </p:childTnLst>
+                          </p:cTn>
+                        </p:par>
+                      </p:childTnLst>
+                    </p:cTn>
+                  </p:par>
+                  <p:par>
+                    <p:cTn id="63" fill="hold">
+                      <p:stCondLst>
+                        <p:cond delay="indefinite"/>
+                      </p:stCondLst>
+                      <p:childTnLst>
+                        <p:par>
+                          <p:cTn id="64" fill="hold">
+                            <p:stCondLst>
+                              <p:cond delay="0"/>
+                            </p:stCondLst>
+                            <p:childTnLst>
+                              <p:par>
+                                <p:cTn id="65" presetID="1" presetClass="entr" presetSubtype="0" fill="hold" grpId="0" nodeType="clickEffect">
+                                  <p:stCondLst>
+                                    <p:cond delay="0"/>
+                                  </p:stCondLst>
+                                  <p:childTnLst>
+                                    <p:set>
+                                      <p:cBhvr>
+                                        <p:cTn id="66" dur="1" fill="hold">
+                                          <p:stCondLst>
+                                            <p:cond delay="0"/>
+                                          </p:stCondLst>
+                                        </p:cTn>
+                                        <p:tgtEl>
+                                          <p:spTgt spid="4">
+                                            <p:txEl>
+                                              <p:pRg st="26" end="26"/>
+                                            </p:txEl>
+                                          </p:spTgt>
+                                        </p:tgtEl>
+                                        <p:attrNameLst>
+                                          <p:attrName>style.visibility</p:attrName>
+                                        </p:attrNameLst>
+                                      </p:cBhvr>
+                                      <p:to>
+                                        <p:strVal val="visible"/>
+                                      </p:to>
+                                    </p:set>
+                                  </p:childTnLst>
+                                </p:cTn>
+                              </p:par>
+                            </p:childTnLst>
+                          </p:cTn>
+                        </p:par>
+                      </p:childTnLst>
+                    </p:cTn>
+                  </p:par>
+                  <p:par>
+                    <p:cTn id="67" fill="hold">
+                      <p:stCondLst>
+                        <p:cond delay="indefinite"/>
+                      </p:stCondLst>
+                      <p:childTnLst>
+                        <p:par>
+                          <p:cTn id="68" fill="hold">
+                            <p:stCondLst>
+                              <p:cond delay="0"/>
+                            </p:stCondLst>
+                            <p:childTnLst>
+                              <p:par>
+                                <p:cTn id="69" presetID="1" presetClass="entr" presetSubtype="0" fill="hold" grpId="0" nodeType="clickEffect">
+                                  <p:stCondLst>
+                                    <p:cond delay="0"/>
+                                  </p:stCondLst>
+                                  <p:childTnLst>
+                                    <p:set>
+                                      <p:cBhvr>
+                                        <p:cTn id="70" dur="1" fill="hold">
+                                          <p:stCondLst>
+                                            <p:cond delay="0"/>
+                                          </p:stCondLst>
+                                        </p:cTn>
+                                        <p:tgtEl>
+                                          <p:spTgt spid="4">
+                                            <p:txEl>
+                                              <p:pRg st="27" end="27"/>
+                                            </p:txEl>
+                                          </p:spTgt>
+                                        </p:tgtEl>
+                                        <p:attrNameLst>
+                                          <p:attrName>style.visibility</p:attrName>
+                                        </p:attrNameLst>
+                                      </p:cBhvr>
+                                      <p:to>
+                                        <p:strVal val="visible"/>
+                                      </p:to>
+                                    </p:set>
+                                  </p:childTnLst>
+                                </p:cTn>
+                              </p:par>
+                            </p:childTnLst>
+                          </p:cTn>
+                        </p:par>
+                      </p:childTnLst>
+                    </p:cTn>
+                  </p:par>
+                  <p:par>
+                    <p:cTn id="71" fill="hold">
+                      <p:stCondLst>
+                        <p:cond delay="indefinite"/>
+                      </p:stCondLst>
+                      <p:childTnLst>
+                        <p:par>
+                          <p:cTn id="72" fill="hold">
+                            <p:stCondLst>
+                              <p:cond delay="0"/>
+                            </p:stCondLst>
+                            <p:childTnLst>
+                              <p:par>
+                                <p:cTn id="73" presetID="1" presetClass="entr" presetSubtype="0" fill="hold" grpId="0" nodeType="clickEffect">
+                                  <p:stCondLst>
+                                    <p:cond delay="0"/>
+                                  </p:stCondLst>
+                                  <p:childTnLst>
+                                    <p:set>
+                                      <p:cBhvr>
+                                        <p:cTn id="74" dur="1" fill="hold">
+                                          <p:stCondLst>
+                                            <p:cond delay="0"/>
+                                          </p:stCondLst>
+                                        </p:cTn>
+                                        <p:tgtEl>
+                                          <p:spTgt spid="4">
+                                            <p:txEl>
+                                              <p:pRg st="28" end="28"/>
+                                            </p:txEl>
+                                          </p:spTgt>
+                                        </p:tgtEl>
+                                        <p:attrNameLst>
+                                          <p:attrName>style.visibility</p:attrName>
+                                        </p:attrNameLst>
+                                      </p:cBhvr>
+                                      <p:to>
+                                        <p:strVal val="visible"/>
+                                      </p:to>
+                                    </p:set>
+                                  </p:childTnLst>
+                                </p:cTn>
+                              </p:par>
+                            </p:childTnLst>
+                          </p:cTn>
+                        </p:par>
+                      </p:childTnLst>
+                    </p:cTn>
+                  </p:par>
+                  <p:par>
+                    <p:cTn id="75" fill="hold">
+                      <p:stCondLst>
+                        <p:cond delay="indefinite"/>
+                      </p:stCondLst>
+                      <p:childTnLst>
+                        <p:par>
+                          <p:cTn id="76" fill="hold">
+                            <p:stCondLst>
+                              <p:cond delay="0"/>
+                            </p:stCondLst>
+                            <p:childTnLst>
+                              <p:par>
+                                <p:cTn id="77" presetID="1" presetClass="entr" presetSubtype="0" fill="hold" grpId="0" nodeType="clickEffect">
+                                  <p:stCondLst>
+                                    <p:cond delay="0"/>
+                                  </p:stCondLst>
+                                  <p:childTnLst>
+                                    <p:set>
+                                      <p:cBhvr>
+                                        <p:cTn id="78" dur="1" fill="hold">
+                                          <p:stCondLst>
+                                            <p:cond delay="0"/>
+                                          </p:stCondLst>
+                                        </p:cTn>
+                                        <p:tgtEl>
+                                          <p:spTgt spid="4">
+                                            <p:txEl>
+                                              <p:pRg st="31" end="31"/>
+                                            </p:txEl>
+                                          </p:spTgt>
+                                        </p:tgtEl>
+                                        <p:attrNameLst>
+                                          <p:attrName>style.visibility</p:attrName>
+                                        </p:attrNameLst>
+                                      </p:cBhvr>
+                                      <p:to>
+                                        <p:strVal val="visible"/>
+                                      </p:to>
+                                    </p:set>
+                                  </p:childTnLst>
+                                </p:cTn>
+                              </p:par>
+                            </p:childTnLst>
+                          </p:cTn>
+                        </p:par>
+                      </p:childTnLst>
+                    </p:cTn>
+                  </p:par>
+                  <p:par>
+                    <p:cTn id="79" fill="hold">
+                      <p:stCondLst>
+                        <p:cond delay="indefinite"/>
+                      </p:stCondLst>
+                      <p:childTnLst>
+                        <p:par>
+                          <p:cTn id="80" fill="hold">
+                            <p:stCondLst>
+                              <p:cond delay="0"/>
+                            </p:stCondLst>
+                            <p:childTnLst>
+                              <p:par>
+                                <p:cTn id="81" presetID="1" presetClass="entr" presetSubtype="0" fill="hold" grpId="0" nodeType="clickEffect">
+                                  <p:stCondLst>
+                                    <p:cond delay="0"/>
+                                  </p:stCondLst>
+                                  <p:childTnLst>
+                                    <p:set>
+                                      <p:cBhvr>
+                                        <p:cTn id="82" dur="1" fill="hold">
+                                          <p:stCondLst>
+                                            <p:cond delay="0"/>
+                                          </p:stCondLst>
+                                        </p:cTn>
+                                        <p:tgtEl>
+                                          <p:spTgt spid="4">
+                                            <p:txEl>
+                                              <p:pRg st="32" end="32"/>
+                                            </p:txEl>
+                                          </p:spTgt>
+                                        </p:tgtEl>
+                                        <p:attrNameLst>
+                                          <p:attrName>style.visibility</p:attrName>
+                                        </p:attrNameLst>
+                                      </p:cBhvr>
+                                      <p:to>
+                                        <p:strVal val="visible"/>
+                                      </p:to>
+                                    </p:set>
+                                  </p:childTnLst>
+                                </p:cTn>
+                              </p:par>
+                            </p:childTnLst>
+                          </p:cTn>
+                        </p:par>
+                      </p:childTnLst>
+                    </p:cTn>
+                  </p:par>
+                  <p:par>
+                    <p:cTn id="83" fill="hold">
+                      <p:stCondLst>
+                        <p:cond delay="indefinite"/>
+                      </p:stCondLst>
+                      <p:childTnLst>
+                        <p:par>
+                          <p:cTn id="84" fill="hold">
+                            <p:stCondLst>
+                              <p:cond delay="0"/>
+                            </p:stCondLst>
+                            <p:childTnLst>
+                              <p:par>
+                                <p:cTn id="85" presetID="1" presetClass="entr" presetSubtype="0" fill="hold" grpId="0" nodeType="clickEffect">
+                                  <p:stCondLst>
+                                    <p:cond delay="0"/>
+                                  </p:stCondLst>
+                                  <p:childTnLst>
+                                    <p:set>
+                                      <p:cBhvr>
+                                        <p:cTn id="86" dur="1" fill="hold">
+                                          <p:stCondLst>
+                                            <p:cond delay="0"/>
+                                          </p:stCondLst>
+                                        </p:cTn>
+                                        <p:tgtEl>
+                                          <p:spTgt spid="4">
+                                            <p:txEl>
+                                              <p:pRg st="33" end="33"/>
+                                            </p:txEl>
+                                          </p:spTgt>
+                                        </p:tgtEl>
+                                        <p:attrNameLst>
+                                          <p:attrName>style.visibility</p:attrName>
+                                        </p:attrNameLst>
+                                      </p:cBhvr>
+                                      <p:to>
+                                        <p:strVal val="visible"/>
+                                      </p:to>
+                                    </p:set>
+                                  </p:childTnLst>
+                                </p:cTn>
+                              </p:par>
+                            </p:childTnLst>
+                          </p:cTn>
+                        </p:par>
+                      </p:childTnLst>
+                    </p:cTn>
+                  </p:par>
+                  <p:par>
+                    <p:cTn id="87" fill="hold">
+                      <p:stCondLst>
+                        <p:cond delay="indefinite"/>
+                      </p:stCondLst>
+                      <p:childTnLst>
+                        <p:par>
+                          <p:cTn id="88" fill="hold">
+                            <p:stCondLst>
+                              <p:cond delay="0"/>
+                            </p:stCondLst>
+                            <p:childTnLst>
+                              <p:par>
+                                <p:cTn id="89" presetID="1" presetClass="entr" presetSubtype="0" fill="hold" grpId="0" nodeType="clickEffect">
+                                  <p:stCondLst>
+                                    <p:cond delay="0"/>
+                                  </p:stCondLst>
+                                  <p:childTnLst>
+                                    <p:set>
+                                      <p:cBhvr>
+                                        <p:cTn id="90" dur="1" fill="hold">
+                                          <p:stCondLst>
+                                            <p:cond delay="0"/>
+                                          </p:stCondLst>
+                                        </p:cTn>
+                                        <p:tgtEl>
+                                          <p:spTgt spid="4">
+                                            <p:txEl>
+                                              <p:pRg st="34" end="34"/>
+                                            </p:txEl>
+                                          </p:spTgt>
+                                        </p:tgtEl>
+                                        <p:attrNameLst>
+                                          <p:attrName>style.visibility</p:attrName>
+                                        </p:attrNameLst>
+                                      </p:cBhvr>
+                                      <p:to>
+                                        <p:strVal val="visible"/>
+                                      </p:to>
+                                    </p:set>
+                                  </p:childTnLst>
+                                </p:cTn>
+                              </p:par>
+                            </p:childTnLst>
+                          </p:cTn>
+                        </p:par>
+                      </p:childTnLst>
+                    </p:cTn>
+                  </p:par>
+                  <p:par>
+                    <p:cTn id="91" fill="hold">
+                      <p:stCondLst>
+                        <p:cond delay="indefinite"/>
+                      </p:stCondLst>
+                      <p:childTnLst>
+                        <p:par>
+                          <p:cTn id="92" fill="hold">
+                            <p:stCondLst>
+                              <p:cond delay="0"/>
+                            </p:stCondLst>
+                            <p:childTnLst>
+                              <p:par>
+                                <p:cTn id="93" presetID="1" presetClass="entr" presetSubtype="0" fill="hold" grpId="0" nodeType="clickEffect">
+                                  <p:stCondLst>
+                                    <p:cond delay="0"/>
+                                  </p:stCondLst>
+                                  <p:childTnLst>
+                                    <p:set>
+                                      <p:cBhvr>
+                                        <p:cTn id="94" dur="1" fill="hold">
+                                          <p:stCondLst>
+                                            <p:cond delay="0"/>
+                                          </p:stCondLst>
+                                        </p:cTn>
+                                        <p:tgtEl>
+                                          <p:spTgt spid="4">
+                                            <p:txEl>
+                                              <p:pRg st="35" end="35"/>
+                                            </p:txEl>
+                                          </p:spTgt>
+                                        </p:tgtEl>
+                                        <p:attrNameLst>
+                                          <p:attrName>style.visibility</p:attrName>
+                                        </p:attrNameLst>
+                                      </p:cBhvr>
+                                      <p:to>
+                                        <p:strVal val="visible"/>
+                                      </p:to>
+                                    </p:set>
+                                  </p:childTnLst>
+                                </p:cTn>
+                              </p:par>
+                            </p:childTnLst>
+                          </p:cTn>
+                        </p:par>
+                      </p:childTnLst>
+                    </p:cTn>
+                  </p:par>
+                  <p:par>
+                    <p:cTn id="95" fill="hold">
+                      <p:stCondLst>
+                        <p:cond delay="indefinite"/>
+                      </p:stCondLst>
+                      <p:childTnLst>
+                        <p:par>
+                          <p:cTn id="96" fill="hold">
+                            <p:stCondLst>
+                              <p:cond delay="0"/>
+                            </p:stCondLst>
+                            <p:childTnLst>
+                              <p:par>
+                                <p:cTn id="97" presetID="1" presetClass="entr" presetSubtype="0" fill="hold" grpId="0" nodeType="clickEffect">
+                                  <p:stCondLst>
+                                    <p:cond delay="0"/>
+                                  </p:stCondLst>
+                                  <p:childTnLst>
+                                    <p:set>
+                                      <p:cBhvr>
+                                        <p:cTn id="98" dur="1" fill="hold">
+                                          <p:stCondLst>
+                                            <p:cond delay="0"/>
+                                          </p:stCondLst>
+                                        </p:cTn>
+                                        <p:tgtEl>
+                                          <p:spTgt spid="4">
+                                            <p:txEl>
+                                              <p:pRg st="36" end="36"/>
+                                            </p:txEl>
+                                          </p:spTgt>
+                                        </p:tgtEl>
+                                        <p:attrNameLst>
+                                          <p:attrName>style.visibility</p:attrName>
+                                        </p:attrNameLst>
+                                      </p:cBhvr>
+                                      <p:to>
+                                        <p:strVal val="visible"/>
+                                      </p:to>
+                                    </p:set>
+                                  </p:childTnLst>
+                                </p:cTn>
+                              </p:par>
+                            </p:childTnLst>
+                          </p:cTn>
+                        </p:par>
+                      </p:childTnLst>
+                    </p:cTn>
+                  </p:par>
+                </p:childTnLst>
+              </p:cTn>
+              <p:prevCondLst>
+                <p:cond evt="onPrev" delay="0">
+                  <p:tgtEl>
+                    <p:sldTgt/>
+                  </p:tgtEl>
+                </p:cond>
+              </p:prevCondLst>
+              <p:nextCondLst>
+                <p:cond evt="onNext" delay="0">
+                  <p:tgtEl>
+                    <p:sldTgt/>
+                  </p:tgtEl>
+                </p:cond>
+              </p:nextCondLst>
+            </p:seq>
+          </p:childTnLst>
+        </p:cTn>
+      </p:par>
+    </p:tnLst>
+    <p:bldLst>
+      <p:bldP spid="4" grpId="0" uiExpand="1" build="p"/>
+    </p:bldLst>
+  </p:timing>
 </p:sld>
 </file>
 
 <file path=ppt/slides/slide15.xml><?xml version="1.0" encoding="utf-8"?>
-<p:sld xmlns:a="http://schemas.openxmlformats.org/drawingml/2006/main" xmlns:r="http://schemas.openxmlformats.org/officeDocument/2006/relationships" xmlns:p="http://schemas.openxmlformats.org/presentationml/2006/main">
-  <p:cSld>
-    <p:spTree>
-      <p:nvGrpSpPr>
-        <p:cNvPr id="1" name=""/>
-        <p:cNvGrpSpPr/>
-        <p:nvPr/>
-      </p:nvGrpSpPr>
-      <p:grpSpPr>
-        <a:xfrm>
-          <a:off x="0" y="0"/>
-          <a:ext cx="0" cy="0"/>
-          <a:chOff x="0" y="0"/>
-          <a:chExt cx="0" cy="0"/>
-        </a:xfrm>
-      </p:grpSpPr>
-      <p:sp>
-        <p:nvSpPr>
-          <p:cNvPr id="3" name="Content Placeholder 2"/>
-          <p:cNvSpPr>
-            <a:spLocks noGrp="1"/>
-          </p:cNvSpPr>
-          <p:nvPr>
-            <p:ph idx="1"/>
-          </p:nvPr>
-        </p:nvSpPr>
-        <p:spPr/>
-        <p:txBody>
-          <a:bodyPr/>
-          <a:lstStyle/>
-          <a:p>
-            <a:pPr lvl="0" indent="0" marL="0">
-              <a:spcBef>
-                <a:spcPts val="3000"/>
-              </a:spcBef>
-              <a:buNone/>
-            </a:pPr>
-            <a:r>
-              <a:rPr b="1"/>
-              <a:t>Guidelines and policies in the epic branch workflow</a:t>
-            </a:r>
-          </a:p>
-          <a:p>
-            <a:pPr lvl="0"/>
-            <a:r>
-              <a:rPr/>
-              <a:t>Frequently synchronize with </a:t>
-            </a:r>
-            <a:r>
-              <a:rPr>
-                <a:latin typeface="Courier"/>
-              </a:rPr>
-              <a:t>main</a:t>
-            </a:r>
-            <a:r>
-              <a:rPr/>
-              <a:t> into the epic branch to avoid making the merge of the </a:t>
-            </a:r>
-            <a:r>
-              <a:rPr>
-                <a:latin typeface="Courier"/>
-              </a:rPr>
-              <a:t>epic</a:t>
-            </a:r>
-            <a:r>
-              <a:rPr/>
-              <a:t> branch into </a:t>
-            </a:r>
-            <a:r>
-              <a:rPr>
-                <a:latin typeface="Courier"/>
-              </a:rPr>
-              <a:t>main</a:t>
-            </a:r>
-            <a:r>
-              <a:rPr/>
-              <a:t> difficult.</a:t>
-            </a:r>
-          </a:p>
-          <a:p>
-            <a:pPr lvl="0"/>
-            <a:r>
-              <a:rPr/>
-              <a:t>Preliminary packages must not be deployed to a production runtime.</a:t>
-            </a:r>
-          </a:p>
-        </p:txBody>
-      </p:sp>
-    </p:spTree>
-  </p:cSld>
-</p:sld>
-</file>
-
-<file path=ppt/slides/slide16.xml><?xml version="1.0" encoding="utf-8"?>
 <p:sld xmlns:a="http://schemas.openxmlformats.org/drawingml/2006/main" xmlns:r="http://schemas.openxmlformats.org/officeDocument/2006/relationships" xmlns:p="http://schemas.openxmlformats.org/presentationml/2006/main">
   <p:cSld>
     <p:spTree>
@@ -4881,23 +6430,54 @@
             </a:pPr>
             <a:r>
               <a:rPr b="1"/>
-              <a:t>Pipeline principles</a:t>
+              <a:t>Pipeline implementation conventions &amp; principles</a:t>
             </a:r>
           </a:p>
           <a:p>
             <a:pPr lvl="0" indent="0" marL="0">
-              <a:buNone/>
-            </a:pPr>
-            <a:r>
-              <a:rPr/>
-              <a:t>Git tags are used to calculate the changes for the next planned release</a:t>
+              <a:spcBef>
+                <a:spcPts val="3000"/>
+              </a:spcBef>
+              <a:buNone/>
+            </a:pPr>
+            <a:r>
+              <a:rPr b="1"/>
+              <a:t>Basic Build pipeline characteristics</a:t>
+            </a:r>
+          </a:p>
+          <a:p>
+            <a:pPr lvl="0"/>
+            <a:r>
+              <a:rPr/>
+              <a:t>(Typically) runs on each commit added to the history of a branch</a:t>
+            </a:r>
+          </a:p>
+          <a:p>
+            <a:pPr lvl="0"/>
+            <a:r>
+              <a:rPr/>
+              <a:t>Can produce a preliminary package that is stored in a binary artifact repository</a:t>
+            </a:r>
+          </a:p>
+          <a:p>
+            <a:pPr lvl="1"/>
+            <a:r>
+              <a:rPr/>
+              <a:t>Can be deployed to test environments, but not production</a:t>
+            </a:r>
+          </a:p>
+          <a:p>
+            <a:pPr lvl="0"/>
+            <a:r>
+              <a:rPr/>
+              <a:t>May include an automated step to deploy it into the DEV-TEST environment</a:t>
             </a:r>
           </a:p>
         </p:txBody>
       </p:sp>
       <p:pic>
         <p:nvPicPr>
-          <p:cNvPr descr="static/img/branching-model/basicBuildPipeline-computeChanges-default-workflow.png" id="0" name="Picture 1"/>
+          <p:cNvPr descr="static/img/branching-model/defaultWorkflow_buildPipelineAfterMerge.png" id="0" name="Picture 1"/>
           <p:cNvPicPr>
             <a:picLocks noGrp="1" noChangeAspect="1"/>
           </p:cNvPicPr>
@@ -4911,8 +6491,8 @@
         </p:blipFill>
         <p:spPr bwMode="auto">
           <a:xfrm>
-            <a:off x="3568700" y="1066800"/>
-            <a:ext cx="5105400" cy="2641600"/>
+            <a:off x="3568700" y="1460500"/>
+            <a:ext cx="5105400" cy="1854200"/>
           </a:xfrm>
           <a:prstGeom prst="rect">
             <a:avLst/>
@@ -4930,7 +6510,7 @@
 </p:sld>
 </file>
 
-<file path=ppt/slides/slide17.xml><?xml version="1.0" encoding="utf-8"?>
+<file path=ppt/slides/slide16.xml><?xml version="1.0" encoding="utf-8"?>
 <p:sld xmlns:a="http://schemas.openxmlformats.org/drawingml/2006/main" xmlns:r="http://schemas.openxmlformats.org/officeDocument/2006/relationships" xmlns:p="http://schemas.openxmlformats.org/presentationml/2006/main">
   <p:cSld>
     <p:spTree>
@@ -4963,15 +6543,6 @@
           <a:lstStyle/>
           <a:p>
             <a:pPr lvl="0" indent="0" marL="0">
-              <a:buNone/>
-            </a:pPr>
-            <a:r>
-              <a:rPr/>
-              <a:t>Packages are always cumulative.</a:t>
-            </a:r>
-          </a:p>
-          <a:p>
-            <a:pPr lvl="0" indent="0" marL="0">
               <a:spcBef>
                 <a:spcPts val="3000"/>
               </a:spcBef>
@@ -4979,61 +6550,7 @@
             </a:pPr>
             <a:r>
               <a:rPr b="1"/>
-              <a:t>Basic Build pipeline</a:t>
-            </a:r>
-          </a:p>
-          <a:p>
-            <a:pPr lvl="0"/>
-            <a:r>
-              <a:rPr/>
-              <a:t>(Typically) runs on each commit added to the history of a branch</a:t>
-            </a:r>
-          </a:p>
-          <a:p>
-            <a:pPr lvl="0"/>
-            <a:r>
-              <a:rPr/>
-              <a:t>Produces a preliminary package that is stored in a binary repository</a:t>
-            </a:r>
-          </a:p>
-          <a:p>
-            <a:pPr lvl="0"/>
-            <a:r>
-              <a:rPr/>
-              <a:t>May include an automated step to deploy it into the DEV-TEST environment</a:t>
-            </a:r>
-          </a:p>
-          <a:p>
-            <a:pPr lvl="0" indent="0" marL="0">
-              <a:spcBef>
-                <a:spcPts val="3000"/>
-              </a:spcBef>
-              <a:buNone/>
-            </a:pPr>
-            <a:r>
-              <a:rPr b="1"/>
               <a:t>Release pipeline</a:t>
-            </a:r>
-          </a:p>
-          <a:p>
-            <a:pPr lvl="0"/>
-            <a:r>
-              <a:rPr/>
-              <a:t>Produces binaries optimized for performance</a:t>
-            </a:r>
-          </a:p>
-          <a:p>
-            <a:pPr lvl="0"/>
-            <a:r>
-              <a:rPr/>
-              <a:t>(Typically) is manually requested by the development team when a level of stability is reached</a:t>
-            </a:r>
-          </a:p>
-          <a:p>
-            <a:pPr lvl="0"/>
-            <a:r>
-              <a:rPr/>
-              <a:t>Produces a release candidate package that can be deployed to higher test environments.</a:t>
             </a:r>
           </a:p>
         </p:txBody>
@@ -5043,7 +6560,7 @@
 </p:sld>
 </file>
 
-<file path=ppt/slides/slide18.xml><?xml version="1.0" encoding="utf-8"?>
+<file path=ppt/slides/slide17.xml><?xml version="1.0" encoding="utf-8"?>
 <p:sld xmlns:a="http://schemas.openxmlformats.org/drawingml/2006/main" xmlns:r="http://schemas.openxmlformats.org/officeDocument/2006/relationships" xmlns:p="http://schemas.openxmlformats.org/presentationml/2006/main">
   <p:cSld>
     <p:spTree>
@@ -5081,6 +6598,34 @@
             <a:r>
               <a:rPr/>
               <a:t>Collateral</a:t>
+            </a:r>
+          </a:p>
+        </p:txBody>
+      </p:sp>
+      <p:sp>
+        <p:nvSpPr>
+          <p:cNvPr id="3" name="Content Placeholder 2"/>
+          <p:cNvSpPr>
+            <a:spLocks noGrp="1"/>
+          </p:cNvSpPr>
+          <p:nvPr>
+            <p:ph idx="1"/>
+          </p:nvPr>
+        </p:nvSpPr>
+        <p:spPr/>
+        <p:txBody>
+          <a:bodyPr/>
+          <a:lstStyle/>
+          <a:p>
+            <a:pPr lvl="0" indent="0" marL="0">
+              <a:spcBef>
+                <a:spcPts val="3000"/>
+              </a:spcBef>
+              <a:buNone/>
+            </a:pPr>
+            <a:r>
+              <a:rPr b="1"/>
+              <a:t>References</a:t>
             </a:r>
           </a:p>
         </p:txBody>
@@ -5447,106 +6992,6 @@
             <a:r>
               <a:rPr/>
               <a:t>We know it is sometimes unavoidable for work to take longer than one release cycle and we accommodate that as a variant of the base workflow.</a:t>
-            </a:r>
-          </a:p>
-          <a:p>
-            <a:pPr lvl="0" indent="0" marL="0">
-              <a:spcBef>
-                <a:spcPts val="3000"/>
-              </a:spcBef>
-              <a:buNone/>
-            </a:pPr>
-            <a:r>
-              <a:rPr b="1"/>
-              <a:t>Convention over configuration</a:t>
-            </a:r>
-          </a:p>
-          <a:p>
-            <a:pPr lvl="0" indent="0" marL="0">
-              <a:buNone/>
-            </a:pPr>
-            <a:r>
-              <a:rPr/>
-              <a:t>The principles are more important that the tools and names.</a:t>
-            </a:r>
-          </a:p>
-          <a:p>
-            <a:pPr lvl="0" indent="0" marL="0">
-              <a:buNone/>
-            </a:pPr>
-            <a:r>
-              <a:rPr/>
-              <a:t>Naming conventions - making purpose obvious:</a:t>
-            </a:r>
-          </a:p>
-          <a:p>
-            <a:pPr lvl="0"/>
-            <a:r>
-              <a:rPr>
-                <a:latin typeface="Courier"/>
-              </a:rPr>
-              <a:t>main</a:t>
-            </a:r>
-            <a:r>
-              <a:rPr/>
-              <a:t>: single source of truth</a:t>
-            </a:r>
-          </a:p>
-          <a:p>
-            <a:pPr lvl="0"/>
-            <a:r>
-              <a:rPr>
-                <a:latin typeface="Courier"/>
-              </a:rPr>
-              <a:t>release/rel-2.0.1</a:t>
-            </a:r>
-            <a:r>
-              <a:rPr/>
-              <a:t>: explicit versioning numbering of releases</a:t>
-            </a:r>
-          </a:p>
-          <a:p>
-            <a:pPr lvl="0"/>
-            <a:r>
-              <a:rPr>
-                <a:latin typeface="Courier"/>
-              </a:rPr>
-              <a:t>feature/&lt;jira-id|servicenow-id&gt;/new-mortage-calculation</a:t>
-            </a:r>
-            <a:r>
-              <a:rPr/>
-              <a:t>: traceable to other processes</a:t>
-            </a:r>
-          </a:p>
-          <a:p>
-            <a:pPr lvl="0"/>
-            <a:r>
-              <a:rPr>
-                <a:latin typeface="Courier"/>
-              </a:rPr>
-              <a:t>epic/ai-fraud-detection</a:t>
-            </a:r>
-            <a:r>
-              <a:rPr/>
-              <a:t>: maybe put Jira or ServiceNow ids in here too</a:t>
-            </a:r>
-          </a:p>
-          <a:p>
-            <a:pPr lvl="0"/>
-            <a:r>
-              <a:rPr>
-                <a:latin typeface="Courier"/>
-              </a:rPr>
-              <a:t>hotfix/rel-2.0.1/fix-mortgage-calc</a:t>
-            </a:r>
-          </a:p>
-          <a:p>
-            <a:pPr lvl="0" indent="0" marL="0">
-              <a:buNone/>
-            </a:pPr>
-            <a:r>
-              <a:rPr/>
-              <a:t>Names of branches and tags flow through to builds and deployments.</a:t>
             </a:r>
           </a:p>
         </p:txBody>

</xml_diff>